<commit_message>
Update Gray Eagle median to $550K and re-flow all figures
Gray Eagle average sale price changed $750K -> $550K. Recomputed from the
model and propagated for internal consistency:
- Gray Eagle: GCI $55,836, net $51,156, ROI 1,093% (was $71,460 / 1,527%)
- Portfolio: net $415,263, GCI $452K, ROI 1,133%, swing vs Zillow $461,759
- Updated cover teaser, Opportunity funnel break-even (~2.4 listings, 12x
  cushion), Downside stress bars, 3-year ramp, Ask slide, and Methodology
  reconciliation + commission-compression tables
- Break-even wording generalized to ~1% (Gray Eagle now 1.26%)

Co-Authored-By: Claude Opus 4.8 <noreply@anthropic.com>
Claude-Session: https://claude.ai/code/session_01Cyq3zkcaFRihnz3XVtX9JE
</commit_message>
<xml_diff>
--- a/presentations/Geo-Farming-Campaign.pptx
+++ b/presentations/Geo-Farming-Campaign.pptx
@@ -199,13 +199,13 @@
                 <c:formatCode>General</c:formatCode>
                 <c:ptCount val="3"/>
                 <c:pt idx="0">
-                  <c:v>152000</c:v>
+                  <c:v>145000</c:v>
                 </c:pt>
                 <c:pt idx="1">
-                  <c:v>294000</c:v>
+                  <c:v>280000</c:v>
                 </c:pt>
                 <c:pt idx="2">
-                  <c:v>436000</c:v>
+                  <c:v>415000</c:v>
                 </c:pt>
               </c:numCache>
             </c:numRef>
@@ -286,7 +286,7 @@
         <c:axId val="2094734552"/>
         <c:scaling>
           <c:orientation val="minMax"/>
-          <c:max val="490000"/>
+          <c:max val="470000"/>
           <c:min val="0"/>
         </c:scaling>
         <c:delete val="1"/>
@@ -2109,7 +2109,7 @@
                 <a:ea typeface="Cambria" pitchFamily="34" charset="-122"/>
                 <a:cs typeface="Cambria" pitchFamily="34" charset="-120"/>
               </a:rPr>
-              <a:t>+$435,567</a:t>
+              <a:t>+$415,263</a:t>
             </a:r>
             <a:endParaRPr lang="en-US" sz="3300" dirty="0"/>
           </a:p>
@@ -2210,7 +2210,7 @@
                 <a:ea typeface="Cambria" pitchFamily="34" charset="-122"/>
                 <a:cs typeface="Cambria" pitchFamily="34" charset="-120"/>
               </a:rPr>
-              <a:t>+$482,063</a:t>
+              <a:t>+$461,759</a:t>
             </a:r>
             <a:endParaRPr lang="en-US" sz="3300" dirty="0"/>
           </a:p>
@@ -3374,7 +3374,7 @@
                 <a:ea typeface="Calibri" pitchFamily="34" charset="-122"/>
                 <a:cs typeface="Calibri" pitchFamily="34" charset="-120"/>
               </a:rPr>
-              <a:t>Just ~2.3 listings a year</a:t>
+              <a:t>Just ~2.4 listings a year</a:t>
             </a:r>
             <a:pPr algn="l" indent="0" marL="0">
               <a:lnSpc>
@@ -3487,7 +3487,7 @@
                 <a:ea typeface="Cambria" pitchFamily="34" charset="-122"/>
                 <a:cs typeface="Cambria" pitchFamily="34" charset="-120"/>
               </a:rPr>
-              <a:t>≈13×</a:t>
+              <a:t>≈12×</a:t>
             </a:r>
             <a:endParaRPr lang="en-US" sz="3800" dirty="0"/>
           </a:p>
@@ -4312,7 +4312,7 @@
                 <a:ea typeface="Calibri" pitchFamily="34" charset="-122"/>
                 <a:cs typeface="Calibri" pitchFamily="34" charset="-120"/>
               </a:rPr>
-              <a:t>A modeled 15% of the winnable pool — against a break-even of under 1%.</a:t>
+              <a:t>A modeled 15% of the winnable pool — against a break-even near 1%.</a:t>
             </a:r>
             <a:endParaRPr lang="en-US" sz="1250" dirty="0"/>
           </a:p>
@@ -4806,7 +4806,7 @@
                 <a:ea typeface="Calibri" pitchFamily="34" charset="-122"/>
                 <a:cs typeface="Calibri" pitchFamily="34" charset="-120"/>
               </a:rPr>
-              <a:t>Cut the 15% capture assumption to a third — 5% — and the portfolio still nets +$120,749. The mail spend is fixed and small; there is no realistic capture rate where this loses money.</a:t>
+              <a:t>Cut the 15% capture assumption to a third — 5% — and the portfolio still nets +$113,981. The mail spend is fixed and small; there is no realistic capture rate where this loses money.</a:t>
             </a:r>
             <a:endParaRPr lang="en-US" sz="1450" dirty="0"/>
           </a:p>
@@ -4906,7 +4906,7 @@
                 <a:ea typeface="Calibri" pitchFamily="34" charset="-122"/>
                 <a:cs typeface="Calibri" pitchFamily="34" charset="-120"/>
               </a:rPr>
-              <a:t>+$435,567</a:t>
+              <a:t>+$415,263</a:t>
             </a:r>
             <a:endParaRPr lang="en-US" sz="1300" dirty="0"/>
           </a:p>
@@ -4960,7 +4960,7 @@
         <p:spPr>
           <a:xfrm>
             <a:off x="4114800" y="3657600"/>
-            <a:ext cx="3591269" cy="420624"/>
+            <a:ext cx="3583555" cy="420624"/>
           </a:xfrm>
           <a:prstGeom prst="roundRect">
             <a:avLst>
@@ -4981,7 +4981,7 @@
         </p:nvSpPr>
         <p:spPr>
           <a:xfrm>
-            <a:off x="7834085" y="3630168"/>
+            <a:off x="7826371" y="3630168"/>
             <a:ext cx="1783080" cy="475488"/>
           </a:xfrm>
           <a:prstGeom prst="rect">
@@ -5006,7 +5006,7 @@
                 <a:ea typeface="Calibri" pitchFamily="34" charset="-122"/>
                 <a:cs typeface="Calibri" pitchFamily="34" charset="-120"/>
               </a:rPr>
-              <a:t>+$278,158</a:t>
+              <a:t>+$264,622</a:t>
             </a:r>
             <a:endParaRPr lang="en-US" sz="1300" dirty="0"/>
           </a:p>
@@ -5060,7 +5060,7 @@
         <p:spPr>
           <a:xfrm>
             <a:off x="4114800" y="4389120"/>
-            <a:ext cx="2575130" cy="420624"/>
+            <a:ext cx="2563559" cy="420624"/>
           </a:xfrm>
           <a:prstGeom prst="roundRect">
             <a:avLst>
@@ -5081,7 +5081,7 @@
         </p:nvSpPr>
         <p:spPr>
           <a:xfrm>
-            <a:off x="6817946" y="4361688"/>
+            <a:off x="6806375" y="4361688"/>
             <a:ext cx="1783080" cy="475488"/>
           </a:xfrm>
           <a:prstGeom prst="rect">
@@ -5106,7 +5106,7 @@
                 <a:ea typeface="Calibri" pitchFamily="34" charset="-122"/>
                 <a:cs typeface="Calibri" pitchFamily="34" charset="-120"/>
               </a:rPr>
-              <a:t>+$199,454</a:t>
+              <a:t>+$189,302</a:t>
             </a:r>
             <a:endParaRPr lang="en-US" sz="1300" dirty="0"/>
           </a:p>
@@ -5160,7 +5160,7 @@
         <p:spPr>
           <a:xfrm>
             <a:off x="4114800" y="5120640"/>
-            <a:ext cx="1558978" cy="420624"/>
+            <a:ext cx="1543549" cy="420624"/>
           </a:xfrm>
           <a:prstGeom prst="roundRect">
             <a:avLst>
@@ -5181,7 +5181,7 @@
         </p:nvSpPr>
         <p:spPr>
           <a:xfrm>
-            <a:off x="5801794" y="5093208"/>
+            <a:off x="5786365" y="5093208"/>
             <a:ext cx="1783080" cy="475488"/>
           </a:xfrm>
           <a:prstGeom prst="rect">
@@ -5206,7 +5206,7 @@
                 <a:ea typeface="Calibri" pitchFamily="34" charset="-122"/>
                 <a:cs typeface="Calibri" pitchFamily="34" charset="-120"/>
               </a:rPr>
-              <a:t>+$120,749</a:t>
+              <a:t>+$113,981</a:t>
             </a:r>
             <a:endParaRPr lang="en-US" sz="1300" dirty="0"/>
           </a:p>
@@ -5248,7 +5248,7 @@
                 <a:ea typeface="Calibri" pitchFamily="34" charset="-122"/>
                 <a:cs typeface="Calibri" pitchFamily="34" charset="-120"/>
               </a:rPr>
-              <a:t>Break-even capture is 0.92%</a:t>
+              <a:t>Break-even capture is around 1%</a:t>
             </a:r>
             <a:pPr algn="l" indent="0" marL="0">
               <a:lnSpc>
@@ -5265,7 +5265,7 @@
                 <a:ea typeface="Calibri" pitchFamily="34" charset="-122"/>
                 <a:cs typeface="Calibri" pitchFamily="34" charset="-120"/>
               </a:rPr>
-              <a:t> — mail is a rounding error next to a ~$28K commission, so every realistic capture rate stays comfortably profitable. Commission-compression sensitivity is in the appendix.</a:t>
+              <a:t> — mail is a rounding error next to the commissions each listing earns, so every realistic capture rate stays comfortably profitable. Commission-compression sensitivity is in the appendix.</a:t>
             </a:r>
             <a:endParaRPr lang="en-US" sz="1150" dirty="0"/>
           </a:p>
@@ -5877,7 +5877,7 @@
                 <a:ea typeface="Cambria" pitchFamily="34" charset="-122"/>
                 <a:cs typeface="Cambria" pitchFamily="34" charset="-120"/>
               </a:rPr>
-              <a:t>$472K</a:t>
+              <a:t>$452K</a:t>
             </a:r>
             <a:endParaRPr lang="en-US" sz="3000" dirty="0"/>
           </a:p>
@@ -6021,7 +6021,7 @@
                 <a:ea typeface="Cambria" pitchFamily="34" charset="-122"/>
                 <a:cs typeface="Cambria" pitchFamily="34" charset="-120"/>
               </a:rPr>
-              <a:t>$435,567</a:t>
+              <a:t>$415,263</a:t>
             </a:r>
             <a:endParaRPr lang="en-US" sz="3000" dirty="0"/>
           </a:p>
@@ -6060,7 +6060,7 @@
                 <a:ea typeface="Calibri" pitchFamily="34" charset="-122"/>
                 <a:cs typeface="Calibri" pitchFamily="34" charset="-120"/>
               </a:rPr>
-              <a:t>≈ 1,088% return on mail</a:t>
+              <a:t>≈ 1,133% return on mail</a:t>
             </a:r>
             <a:endParaRPr lang="en-US" sz="1050" dirty="0"/>
           </a:p>
@@ -7180,7 +7180,7 @@
                           <a:ea typeface="Calibri" pitchFamily="34" charset="-122"/>
                           <a:cs typeface="Calibri" pitchFamily="34" charset="-120"/>
                         </a:rPr>
-                        <a:t>$750K</a:t>
+                        <a:t>$550K</a:t>
                       </a:r>
                       <a:endParaRPr lang="en-US" sz="1250" dirty="0">
                         <a:latin typeface="Calibri" charset="0"/>
@@ -7375,7 +7375,7 @@
                           <a:ea typeface="Calibri" pitchFamily="34" charset="-122"/>
                           <a:cs typeface="Calibri" pitchFamily="34" charset="-120"/>
                         </a:rPr>
-                        <a:t>$71,460</a:t>
+                        <a:t>$51,156</a:t>
                       </a:r>
                       <a:endParaRPr lang="en-US" sz="1250" dirty="0">
                         <a:latin typeface="Calibri" charset="0"/>
@@ -7440,7 +7440,7 @@
                           <a:ea typeface="Calibri" pitchFamily="34" charset="-122"/>
                           <a:cs typeface="Calibri" pitchFamily="34" charset="-120"/>
                         </a:rPr>
-                        <a:t>1,527%</a:t>
+                        <a:t>1,093%</a:t>
                       </a:r>
                       <a:endParaRPr lang="en-US" sz="1250" dirty="0">
                         <a:latin typeface="Calibri" charset="0"/>
@@ -8310,7 +8310,7 @@
                           <a:ea typeface="Calibri" pitchFamily="34" charset="-122"/>
                           <a:cs typeface="Calibri" pitchFamily="34" charset="-120"/>
                         </a:rPr>
-                        <a:t>$435,567</a:t>
+                        <a:t>$415,263</a:t>
                       </a:r>
                       <a:endParaRPr lang="en-US" sz="1250" dirty="0">
                         <a:latin typeface="Calibri" charset="0"/>
@@ -8375,7 +8375,7 @@
                           <a:ea typeface="Calibri" pitchFamily="34" charset="-122"/>
                           <a:cs typeface="Calibri" pitchFamily="34" charset="-120"/>
                         </a:rPr>
-                        <a:t>1,088%</a:t>
+                        <a:t>1,133%</a:t>
                       </a:r>
                       <a:endParaRPr lang="en-US" sz="1250" dirty="0">
                         <a:latin typeface="Calibri" charset="0"/>
@@ -10112,7 +10112,7 @@
                 <a:ea typeface="Calibri" pitchFamily="34" charset="-122"/>
                 <a:cs typeface="Calibri" pitchFamily="34" charset="-120"/>
               </a:rPr>
-              <a:t>−$46,496 becomes +$435,567 at full ramp.</a:t>
+              <a:t>−$46,496 becomes +$415,263 at full ramp.</a:t>
             </a:r>
             <a:endParaRPr lang="en-US" sz="1100" dirty="0"/>
           </a:p>
@@ -10491,7 +10491,7 @@
                 <a:ea typeface="Cambria" pitchFamily="34" charset="-122"/>
                 <a:cs typeface="Cambria" pitchFamily="34" charset="-120"/>
               </a:rPr>
-              <a:t>+$482,063   </a:t>
+              <a:t>+$461,759   </a:t>
             </a:r>
             <a:pPr algn="r" indent="0" marL="0">
               <a:buNone/>
@@ -11968,7 +11968,7 @@
                           <a:ea typeface="Calibri" pitchFamily="34" charset="-122"/>
                           <a:cs typeface="Calibri" pitchFamily="34" charset="-120"/>
                         </a:rPr>
-                        <a:t>$76,140</a:t>
+                        <a:t>$55,836</a:t>
                       </a:r>
                       <a:endParaRPr lang="en-US" sz="1150" dirty="0">
                         <a:latin typeface="Calibri" charset="0"/>
@@ -12165,7 +12165,7 @@
                           <a:ea typeface="Calibri" pitchFamily="34" charset="-122"/>
                           <a:cs typeface="Calibri" pitchFamily="34" charset="-120"/>
                         </a:rPr>
-                        <a:t>$71,460</a:t>
+                        <a:t>$51,156</a:t>
                       </a:r>
                       <a:endParaRPr lang="en-US" sz="1150" dirty="0">
                         <a:latin typeface="Calibri" charset="0"/>
@@ -12564,7 +12564,7 @@
                           <a:ea typeface="Calibri" pitchFamily="34" charset="-122"/>
                           <a:cs typeface="Calibri" pitchFamily="34" charset="-120"/>
                         </a:rPr>
-                        <a:t>$472K</a:t>
+                        <a:t>$452K</a:t>
                       </a:r>
                       <a:endParaRPr lang="en-US" sz="1150" dirty="0">
                         <a:latin typeface="Calibri" charset="0"/>
@@ -12629,7 +12629,7 @@
                           <a:ea typeface="Calibri" pitchFamily="34" charset="-122"/>
                           <a:cs typeface="Calibri" pitchFamily="34" charset="-120"/>
                         </a:rPr>
-                        <a:t>$435,567</a:t>
+                        <a:t>$415,263</a:t>
                       </a:r>
                       <a:endParaRPr lang="en-US" sz="1150" dirty="0">
                         <a:latin typeface="Calibri" charset="0"/>
@@ -12761,7 +12761,7 @@
                           <a:ea typeface="Calibri" pitchFamily="34" charset="-122"/>
                           <a:cs typeface="Calibri" pitchFamily="34" charset="-120"/>
                         </a:rPr>
-                        <a:t>$419K</a:t>
+                        <a:t>$401K</a:t>
                       </a:r>
                       <a:endParaRPr lang="en-US" sz="1150" dirty="0">
                         <a:latin typeface="Calibri" charset="0"/>
@@ -12826,7 +12826,7 @@
                           <a:ea typeface="Calibri" pitchFamily="34" charset="-122"/>
                           <a:cs typeface="Calibri" pitchFamily="34" charset="-120"/>
                         </a:rPr>
-                        <a:t>$381,990</a:t>
+                        <a:t>$363,981</a:t>
                       </a:r>
                       <a:endParaRPr lang="en-US" sz="1150" dirty="0">
                         <a:latin typeface="Calibri" charset="0"/>
@@ -12958,7 +12958,7 @@
                           <a:ea typeface="Calibri" pitchFamily="34" charset="-122"/>
                           <a:cs typeface="Calibri" pitchFamily="34" charset="-120"/>
                         </a:rPr>
-                        <a:t>$385K</a:t>
+                        <a:t>$369K</a:t>
                       </a:r>
                       <a:endParaRPr lang="en-US" sz="1150" dirty="0">
                         <a:latin typeface="Calibri" charset="0"/>
@@ -13023,7 +13023,7 @@
                           <a:ea typeface="Calibri" pitchFamily="34" charset="-122"/>
                           <a:cs typeface="Calibri" pitchFamily="34" charset="-120"/>
                         </a:rPr>
-                        <a:t>$348,490</a:t>
+                        <a:t>$331,930</a:t>
                       </a:r>
                       <a:endParaRPr lang="en-US" sz="1150" dirty="0">
                         <a:latin typeface="Calibri" charset="0"/>

</xml_diff>

<commit_message>
Clean title slide and drop seeded-farms row
- Title slide: removed the stat teaser, the descriptive subtitle, and the
  numeric facility tagline; recentered the title. No numbers remain.
- Portfolio table: removed the 'Four seeded farms — combined' row; kept the
  Portfolio total and the footnote that accounts for those four farms.

Co-Authored-By: Claude Opus 4.8 <noreply@anthropic.com>
Claude-Session: https://claude.ai/code/session_01Cyq3zkcaFRihnz3XVtX9JE
</commit_message>
<xml_diff>
--- a/presentations/Geo-Farming-Campaign.pptx
+++ b/presentations/Geo-Farming-Campaign.pptx
@@ -1851,7 +1851,7 @@
         </p:nvSpPr>
         <p:spPr>
           <a:xfrm>
-            <a:off x="640080" y="2148840"/>
+            <a:off x="640080" y="2788920"/>
             <a:ext cx="10607040" cy="1188720"/>
           </a:xfrm>
           <a:prstGeom prst="rect">
@@ -1918,8 +1918,8 @@
         </p:nvSpPr>
         <p:spPr>
           <a:xfrm>
-            <a:off x="640080" y="3429000"/>
-            <a:ext cx="7863840" cy="822960"/>
+            <a:off x="640080" y="6263640"/>
+            <a:ext cx="8229600" cy="365760"/>
           </a:xfrm>
           <a:prstGeom prst="rect">
             <a:avLst/>
@@ -1932,114 +1932,38 @@
           <a:lstStyle/>
           <a:p>
             <a:pPr algn="l" indent="0" marL="0">
-              <a:lnSpc>
-                <a:spcPct val="105000"/>
-              </a:lnSpc>
-              <a:buNone/>
-            </a:pPr>
-            <a:r>
-              <a:rPr lang="en-US" sz="1550" dirty="0">
-                <a:solidFill>
-                  <a:srgbClr val="C9D3E4"/>
-                </a:solidFill>
-                <a:latin typeface="Calibri" pitchFamily="34" charset="0"/>
-                <a:ea typeface="Calibri" pitchFamily="34" charset="-122"/>
-                <a:cs typeface="Calibri" pitchFamily="34" charset="-120"/>
-              </a:rPr>
-              <a:t>A data-underwritten geo-farming portfolio across six Hamilton County communities — built to deploy marketing capital with measurable, downside-protected ROI.</a:t>
-            </a:r>
-            <a:endParaRPr lang="en-US" sz="1550" dirty="0"/>
-          </a:p>
-        </p:txBody>
-      </p:sp>
-      <p:sp>
-        <p:nvSpPr>
-          <p:cNvPr id="7" name="Shape 5"/>
-          <p:cNvSpPr/>
-          <p:nvPr/>
-        </p:nvSpPr>
-        <p:spPr>
-          <a:xfrm>
-            <a:off x="640080" y="4892040"/>
-            <a:ext cx="2468880" cy="0"/>
-          </a:xfrm>
-          <a:prstGeom prst="line">
-            <a:avLst/>
-          </a:prstGeom>
-          <a:noFill/>
-          <a:ln w="12700">
-            <a:solidFill>
-              <a:srgbClr val="6E5A2E"/>
-            </a:solidFill>
-            <a:prstDash val="solid"/>
-          </a:ln>
-        </p:spPr>
-      </p:sp>
-      <p:sp>
-        <p:nvSpPr>
-          <p:cNvPr id="8" name="Text 6"/>
-          <p:cNvSpPr/>
-          <p:nvPr/>
-        </p:nvSpPr>
-        <p:spPr>
-          <a:xfrm>
-            <a:off x="640080" y="4983480"/>
-            <a:ext cx="2651760" cy="548640"/>
-          </a:xfrm>
-          <a:prstGeom prst="rect">
-            <a:avLst/>
-          </a:prstGeom>
-          <a:noFill/>
-          <a:ln/>
-        </p:spPr>
-        <p:txBody>
-          <a:bodyPr wrap="square" rtlCol="0" anchor="ctr"/>
-          <a:lstStyle/>
-          <a:p>
+              <a:buNone/>
+            </a:pPr>
+            <a:r>
+              <a:rPr lang="en-US" sz="1100" dirty="0">
+                <a:solidFill>
+                  <a:srgbClr val="9A9482"/>
+                </a:solidFill>
+                <a:latin typeface="Calibri" pitchFamily="34" charset="0"/>
+                <a:ea typeface="Calibri" pitchFamily="34" charset="-122"/>
+                <a:cs typeface="Calibri" pitchFamily="34" charset="-120"/>
+              </a:rPr>
+              <a:t>Presented by </a:t>
+            </a:r>
             <a:pPr algn="l" indent="0" marL="0">
               <a:buNone/>
             </a:pPr>
             <a:r>
-              <a:rPr lang="en-US" sz="3300" b="1" dirty="0">
+              <a:rPr lang="en-US" sz="1100" b="1" dirty="0">
                 <a:solidFill>
                   <a:srgbClr val="E7E0CE"/>
                 </a:solidFill>
-                <a:latin typeface="Cambria" pitchFamily="34" charset="0"/>
-                <a:ea typeface="Cambria" pitchFamily="34" charset="-122"/>
-                <a:cs typeface="Cambria" pitchFamily="34" charset="-120"/>
-              </a:rPr>
-              <a:t>−$46,496</a:t>
-            </a:r>
-            <a:endParaRPr lang="en-US" sz="3300" dirty="0"/>
-          </a:p>
-        </p:txBody>
-      </p:sp>
-      <p:sp>
-        <p:nvSpPr>
-          <p:cNvPr id="9" name="Text 7"/>
-          <p:cNvSpPr/>
-          <p:nvPr/>
-        </p:nvSpPr>
-        <p:spPr>
-          <a:xfrm>
-            <a:off x="640080" y="5559552"/>
-            <a:ext cx="2743200" cy="274320"/>
-          </a:xfrm>
-          <a:prstGeom prst="rect">
-            <a:avLst/>
-          </a:prstGeom>
-          <a:noFill/>
-          <a:ln/>
-        </p:spPr>
-        <p:txBody>
-          <a:bodyPr wrap="square" rtlCol="0" anchor="ctr"/>
-          <a:lstStyle/>
-          <a:p>
+                <a:latin typeface="Calibri" pitchFamily="34" charset="0"/>
+                <a:ea typeface="Calibri" pitchFamily="34" charset="-122"/>
+                <a:cs typeface="Calibri" pitchFamily="34" charset="-120"/>
+              </a:rPr>
+              <a:t>Jones Real Estate Team</a:t>
+            </a:r>
             <a:pPr algn="l" indent="0" marL="0">
               <a:buNone/>
             </a:pPr>
             <a:r>
-              <a:rPr lang="en-US" sz="950" spc="80" kern="0" dirty="0">
+              <a:rPr lang="en-US" sz="1100" dirty="0">
                 <a:solidFill>
                   <a:srgbClr val="9A9482"/>
                 </a:solidFill>
@@ -2047,336 +1971,7 @@
                 <a:ea typeface="Calibri" pitchFamily="34" charset="-122"/>
                 <a:cs typeface="Calibri" pitchFamily="34" charset="-120"/>
               </a:rPr>
-              <a:t>ZILLOW CHANNEL · NET / YR</a:t>
-            </a:r>
-            <a:endParaRPr lang="en-US" sz="950" dirty="0"/>
-          </a:p>
-        </p:txBody>
-      </p:sp>
-      <p:sp>
-        <p:nvSpPr>
-          <p:cNvPr id="10" name="Shape 8"/>
-          <p:cNvSpPr/>
-          <p:nvPr/>
-        </p:nvSpPr>
-        <p:spPr>
-          <a:xfrm>
-            <a:off x="3520440" y="4892040"/>
-            <a:ext cx="2468880" cy="0"/>
-          </a:xfrm>
-          <a:prstGeom prst="line">
-            <a:avLst/>
-          </a:prstGeom>
-          <a:noFill/>
-          <a:ln w="12700">
-            <a:solidFill>
-              <a:srgbClr val="6E5A2E"/>
-            </a:solidFill>
-            <a:prstDash val="solid"/>
-          </a:ln>
-        </p:spPr>
-      </p:sp>
-      <p:sp>
-        <p:nvSpPr>
-          <p:cNvPr id="11" name="Text 9"/>
-          <p:cNvSpPr/>
-          <p:nvPr/>
-        </p:nvSpPr>
-        <p:spPr>
-          <a:xfrm>
-            <a:off x="3520440" y="4983480"/>
-            <a:ext cx="2651760" cy="548640"/>
-          </a:xfrm>
-          <a:prstGeom prst="rect">
-            <a:avLst/>
-          </a:prstGeom>
-          <a:noFill/>
-          <a:ln/>
-        </p:spPr>
-        <p:txBody>
-          <a:bodyPr wrap="square" rtlCol="0" anchor="ctr"/>
-          <a:lstStyle/>
-          <a:p>
-            <a:pPr algn="l" indent="0" marL="0">
-              <a:buNone/>
-            </a:pPr>
-            <a:r>
-              <a:rPr lang="en-US" sz="3300" b="1" dirty="0">
-                <a:solidFill>
-                  <a:srgbClr val="B0842F"/>
-                </a:solidFill>
-                <a:latin typeface="Cambria" pitchFamily="34" charset="0"/>
-                <a:ea typeface="Cambria" pitchFamily="34" charset="-122"/>
-                <a:cs typeface="Cambria" pitchFamily="34" charset="-120"/>
-              </a:rPr>
-              <a:t>+$415,263</a:t>
-            </a:r>
-            <a:endParaRPr lang="en-US" sz="3300" dirty="0"/>
-          </a:p>
-        </p:txBody>
-      </p:sp>
-      <p:sp>
-        <p:nvSpPr>
-          <p:cNvPr id="12" name="Text 10"/>
-          <p:cNvSpPr/>
-          <p:nvPr/>
-        </p:nvSpPr>
-        <p:spPr>
-          <a:xfrm>
-            <a:off x="3520440" y="5559552"/>
-            <a:ext cx="2743200" cy="274320"/>
-          </a:xfrm>
-          <a:prstGeom prst="rect">
-            <a:avLst/>
-          </a:prstGeom>
-          <a:noFill/>
-          <a:ln/>
-        </p:spPr>
-        <p:txBody>
-          <a:bodyPr wrap="square" rtlCol="0" anchor="ctr"/>
-          <a:lstStyle/>
-          <a:p>
-            <a:pPr algn="l" indent="0" marL="0">
-              <a:buNone/>
-            </a:pPr>
-            <a:r>
-              <a:rPr lang="en-US" sz="950" spc="80" kern="0" dirty="0">
-                <a:solidFill>
-                  <a:srgbClr val="9A9482"/>
-                </a:solidFill>
-                <a:latin typeface="Calibri" pitchFamily="34" charset="0"/>
-                <a:ea typeface="Calibri" pitchFamily="34" charset="-122"/>
-                <a:cs typeface="Calibri" pitchFamily="34" charset="-120"/>
-              </a:rPr>
-              <a:t>GEO-FARM PORTFOLIO · NET / YR</a:t>
-            </a:r>
-            <a:endParaRPr lang="en-US" sz="950" dirty="0"/>
-          </a:p>
-        </p:txBody>
-      </p:sp>
-      <p:sp>
-        <p:nvSpPr>
-          <p:cNvPr id="13" name="Shape 11"/>
-          <p:cNvSpPr/>
-          <p:nvPr/>
-        </p:nvSpPr>
-        <p:spPr>
-          <a:xfrm>
-            <a:off x="6400800" y="4892040"/>
-            <a:ext cx="2468880" cy="0"/>
-          </a:xfrm>
-          <a:prstGeom prst="line">
-            <a:avLst/>
-          </a:prstGeom>
-          <a:noFill/>
-          <a:ln w="12700">
-            <a:solidFill>
-              <a:srgbClr val="6E5A2E"/>
-            </a:solidFill>
-            <a:prstDash val="solid"/>
-          </a:ln>
-        </p:spPr>
-      </p:sp>
-      <p:sp>
-        <p:nvSpPr>
-          <p:cNvPr id="14" name="Text 12"/>
-          <p:cNvSpPr/>
-          <p:nvPr/>
-        </p:nvSpPr>
-        <p:spPr>
-          <a:xfrm>
-            <a:off x="6400800" y="4983480"/>
-            <a:ext cx="2651760" cy="548640"/>
-          </a:xfrm>
-          <a:prstGeom prst="rect">
-            <a:avLst/>
-          </a:prstGeom>
-          <a:noFill/>
-          <a:ln/>
-        </p:spPr>
-        <p:txBody>
-          <a:bodyPr wrap="square" rtlCol="0" anchor="ctr"/>
-          <a:lstStyle/>
-          <a:p>
-            <a:pPr algn="l" indent="0" marL="0">
-              <a:buNone/>
-            </a:pPr>
-            <a:r>
-              <a:rPr lang="en-US" sz="3300" b="1" dirty="0">
-                <a:solidFill>
-                  <a:srgbClr val="B0842F"/>
-                </a:solidFill>
-                <a:latin typeface="Cambria" pitchFamily="34" charset="0"/>
-                <a:ea typeface="Cambria" pitchFamily="34" charset="-122"/>
-                <a:cs typeface="Cambria" pitchFamily="34" charset="-120"/>
-              </a:rPr>
-              <a:t>+$461,759</a:t>
-            </a:r>
-            <a:endParaRPr lang="en-US" sz="3300" dirty="0"/>
-          </a:p>
-        </p:txBody>
-      </p:sp>
-      <p:sp>
-        <p:nvSpPr>
-          <p:cNvPr id="15" name="Text 13"/>
-          <p:cNvSpPr/>
-          <p:nvPr/>
-        </p:nvSpPr>
-        <p:spPr>
-          <a:xfrm>
-            <a:off x="6400800" y="5559552"/>
-            <a:ext cx="2743200" cy="274320"/>
-          </a:xfrm>
-          <a:prstGeom prst="rect">
-            <a:avLst/>
-          </a:prstGeom>
-          <a:noFill/>
-          <a:ln/>
-        </p:spPr>
-        <p:txBody>
-          <a:bodyPr wrap="square" rtlCol="0" anchor="ctr"/>
-          <a:lstStyle/>
-          <a:p>
-            <a:pPr algn="l" indent="0" marL="0">
-              <a:buNone/>
-            </a:pPr>
-            <a:r>
-              <a:rPr lang="en-US" sz="950" spc="80" kern="0" dirty="0">
-                <a:solidFill>
-                  <a:srgbClr val="9A9482"/>
-                </a:solidFill>
-                <a:latin typeface="Calibri" pitchFamily="34" charset="0"/>
-                <a:ea typeface="Calibri" pitchFamily="34" charset="-122"/>
-                <a:cs typeface="Calibri" pitchFamily="34" charset="-120"/>
-              </a:rPr>
-              <a:t>ANNUAL SWING</a:t>
-            </a:r>
-            <a:endParaRPr lang="en-US" sz="950" dirty="0"/>
-          </a:p>
-        </p:txBody>
-      </p:sp>
-      <p:sp>
-        <p:nvSpPr>
-          <p:cNvPr id="16" name="Text 14"/>
-          <p:cNvSpPr/>
-          <p:nvPr/>
-        </p:nvSpPr>
-        <p:spPr>
-          <a:xfrm>
-            <a:off x="640080" y="6263640"/>
-            <a:ext cx="7315200" cy="365760"/>
-          </a:xfrm>
-          <a:prstGeom prst="rect">
-            <a:avLst/>
-          </a:prstGeom>
-          <a:noFill/>
-          <a:ln/>
-        </p:spPr>
-        <p:txBody>
-          <a:bodyPr wrap="square" rtlCol="0" anchor="ctr"/>
-          <a:lstStyle/>
-          <a:p>
-            <a:pPr algn="l" indent="0" marL="0">
-              <a:buNone/>
-            </a:pPr>
-            <a:r>
-              <a:rPr lang="en-US" sz="1100" dirty="0">
-                <a:solidFill>
-                  <a:srgbClr val="9A9482"/>
-                </a:solidFill>
-                <a:latin typeface="Calibri" pitchFamily="34" charset="0"/>
-                <a:ea typeface="Calibri" pitchFamily="34" charset="-122"/>
-                <a:cs typeface="Calibri" pitchFamily="34" charset="-120"/>
-              </a:rPr>
-              <a:t>Presented by </a:t>
-            </a:r>
-            <a:pPr algn="l" indent="0" marL="0">
-              <a:buNone/>
-            </a:pPr>
-            <a:r>
-              <a:rPr lang="en-US" sz="1100" b="1" dirty="0">
-                <a:solidFill>
-                  <a:srgbClr val="E7E0CE"/>
-                </a:solidFill>
-                <a:latin typeface="Calibri" pitchFamily="34" charset="0"/>
-                <a:ea typeface="Calibri" pitchFamily="34" charset="-122"/>
-                <a:cs typeface="Calibri" pitchFamily="34" charset="-120"/>
-              </a:rPr>
-              <a:t>Jones Real Estate Team</a:t>
-            </a:r>
-            <a:pPr algn="l" indent="0" marL="0">
-              <a:buNone/>
-            </a:pPr>
-            <a:r>
-              <a:rPr lang="en-US" sz="1100" dirty="0">
-                <a:solidFill>
-                  <a:srgbClr val="9A9482"/>
-                </a:solidFill>
-                <a:latin typeface="Calibri" pitchFamily="34" charset="0"/>
-                <a:ea typeface="Calibri" pitchFamily="34" charset="-122"/>
-                <a:cs typeface="Calibri" pitchFamily="34" charset="-120"/>
-              </a:rPr>
               <a:t>   ·   Hamilton County, Indiana · MIBOR market</a:t>
-            </a:r>
-            <a:endParaRPr lang="en-US" sz="1100" dirty="0"/>
-          </a:p>
-        </p:txBody>
-      </p:sp>
-      <p:sp>
-        <p:nvSpPr>
-          <p:cNvPr id="17" name="Text 15"/>
-          <p:cNvSpPr/>
-          <p:nvPr/>
-        </p:nvSpPr>
-        <p:spPr>
-          <a:xfrm>
-            <a:off x="6979615" y="6217920"/>
-            <a:ext cx="4572000" cy="457200"/>
-          </a:xfrm>
-          <a:prstGeom prst="rect">
-            <a:avLst/>
-          </a:prstGeom>
-          <a:noFill/>
-          <a:ln/>
-        </p:spPr>
-        <p:txBody>
-          <a:bodyPr wrap="square" rtlCol="0" anchor="ctr"/>
-          <a:lstStyle/>
-          <a:p>
-            <a:pPr algn="r" indent="0" marL="0">
-              <a:lnSpc>
-                <a:spcPct val="110000"/>
-              </a:lnSpc>
-              <a:buNone/>
-            </a:pPr>
-            <a:r>
-              <a:rPr lang="en-US" sz="1100" dirty="0">
-                <a:solidFill>
-                  <a:srgbClr val="9A9482"/>
-                </a:solidFill>
-                <a:latin typeface="Calibri" pitchFamily="34" charset="0"/>
-                <a:ea typeface="Calibri" pitchFamily="34" charset="-122"/>
-                <a:cs typeface="Calibri" pitchFamily="34" charset="-120"/>
-              </a:rPr>
-              <a:t>Marketing Capital &amp; Ad-Spend Facility
-</a:t>
-            </a:r>
-            <a:pPr algn="r" indent="0" marL="0">
-              <a:lnSpc>
-                <a:spcPct val="110000"/>
-              </a:lnSpc>
-              <a:buNone/>
-            </a:pPr>
-            <a:r>
-              <a:rPr lang="en-US" sz="1100" b="1" dirty="0">
-                <a:solidFill>
-                  <a:srgbClr val="E7E0CE"/>
-                </a:solidFill>
-                <a:latin typeface="Calibri" pitchFamily="34" charset="0"/>
-                <a:ea typeface="Calibri" pitchFamily="34" charset="-122"/>
-                <a:cs typeface="Calibri" pitchFamily="34" charset="-120"/>
-              </a:rPr>
-              <a:t>Requested: growth capital for a 6-farm rollout</a:t>
             </a:r>
             <a:endParaRPr lang="en-US" sz="1100" dirty="0"/>
           </a:p>
@@ -6081,7 +5676,7 @@
           </p:nvPr>
         </p:nvGraphicFramePr>
         <p:xfrm>
-          <a:off x="640080" y="3246120"/>
+          <a:off x="640080" y="3383280"/>
           <a:ext cx="10881360" cy="914400"/>
         </p:xfrm>
         <a:graphic>
@@ -6097,7 +5692,7 @@
                 <a:gridCol w="1463040"/>
                 <a:gridCol w="1097280"/>
               </a:tblGrid>
-              <a:tr h="347472">
+              <a:tr h="384048">
                 <a:tc>
                   <a:txBody>
                     <a:bodyPr/>
@@ -6575,7 +6170,7 @@
                   </a:tcPr>
                 </a:tc>
               </a:tr>
-              <a:tr h="457200">
+              <a:tr h="512064">
                 <a:tc>
                   <a:txBody>
                     <a:bodyPr/>
@@ -7032,7 +6627,7 @@
                   </a:tcPr>
                 </a:tc>
               </a:tr>
-              <a:tr h="457200">
+              <a:tr h="512064">
                 <a:tc>
                   <a:txBody>
                     <a:bodyPr/>
@@ -7489,485 +7084,7 @@
                   </a:tcPr>
                 </a:tc>
               </a:tr>
-              <a:tr h="457200">
-                <a:tc>
-                  <a:txBody>
-                    <a:bodyPr/>
-                    <a:lstStyle/>
-                    <a:p>
-                      <a:pPr algn="l" indent="0" marL="0">
-                        <a:buNone/>
-                      </a:pPr>
-                      <a:r>
-                        <a:rPr lang="en-US" sz="1250" b="1" dirty="0">
-                          <a:solidFill>
-                            <a:srgbClr val="1B160B"/>
-                          </a:solidFill>
-                          <a:latin typeface="Calibri" pitchFamily="34" charset="0"/>
-                          <a:ea typeface="Calibri" pitchFamily="34" charset="-122"/>
-                          <a:cs typeface="Calibri" pitchFamily="34" charset="-120"/>
-                        </a:rPr>
-                        <a:t>Four seeded farms — combined</a:t>
-                      </a:r>
-                      <a:endParaRPr lang="en-US" sz="1250" dirty="0">
-                        <a:latin typeface="Calibri" charset="0"/>
-                        <a:ea typeface="Calibri" charset="0"/>
-                        <a:cs typeface="Calibri" charset="0"/>
-                      </a:endParaRPr>
-                    </a:p>
-                  </a:txBody>
-                  <a:tcPr marL="76200" marR="76200" marT="25400" marB="25400" anchor="ctr">
-                    <a:lnL w="12700" cap="flat" cmpd="sng" algn="ctr">
-                      <a:solidFill>
-                        <a:srgbClr val="E4DDCB"/>
-                      </a:solidFill>
-                      <a:prstDash val="solid"/>
-                      <a:round/>
-                      <a:headEnd type="none" w="med" len="med"/>
-                      <a:tailEnd type="none" w="med" len="med"/>
-                    </a:lnL>
-                    <a:lnR w="12700" cap="flat" cmpd="sng" algn="ctr">
-                      <a:solidFill>
-                        <a:srgbClr val="E4DDCB"/>
-                      </a:solidFill>
-                      <a:prstDash val="solid"/>
-                      <a:round/>
-                      <a:headEnd type="none" w="med" len="med"/>
-                      <a:tailEnd type="none" w="med" len="med"/>
-                    </a:lnR>
-                    <a:lnT w="12700" cap="flat" cmpd="sng" algn="ctr">
-                      <a:solidFill>
-                        <a:srgbClr val="E4DDCB"/>
-                      </a:solidFill>
-                      <a:prstDash val="solid"/>
-                      <a:round/>
-                      <a:headEnd type="none" w="med" len="med"/>
-                      <a:tailEnd type="none" w="med" len="med"/>
-                    </a:lnT>
-                    <a:lnB w="12700" cap="flat" cmpd="sng" algn="ctr">
-                      <a:solidFill>
-                        <a:srgbClr val="E4DDCB"/>
-                      </a:solidFill>
-                      <a:prstDash val="solid"/>
-                      <a:round/>
-                      <a:headEnd type="none" w="med" len="med"/>
-                      <a:tailEnd type="none" w="med" len="med"/>
-                    </a:lnB>
-                    <a:solidFill>
-                      <a:srgbClr val="F5F0E4"/>
-                    </a:solidFill>
-                  </a:tcPr>
-                </a:tc>
-                <a:tc>
-                  <a:txBody>
-                    <a:bodyPr/>
-                    <a:lstStyle/>
-                    <a:p>
-                      <a:pPr algn="r" indent="0" marL="0">
-                        <a:buNone/>
-                      </a:pPr>
-                      <a:r>
-                        <a:rPr lang="en-US" sz="1250" dirty="0">
-                          <a:solidFill>
-                            <a:srgbClr val="1B160B"/>
-                          </a:solidFill>
-                          <a:latin typeface="Calibri" pitchFamily="34" charset="0"/>
-                          <a:ea typeface="Calibri" pitchFamily="34" charset="-122"/>
-                          <a:cs typeface="Calibri" pitchFamily="34" charset="-120"/>
-                        </a:rPr>
-                        <a:t>~3,350</a:t>
-                      </a:r>
-                      <a:endParaRPr lang="en-US" sz="1250" dirty="0">
-                        <a:latin typeface="Calibri" charset="0"/>
-                        <a:ea typeface="Calibri" charset="0"/>
-                        <a:cs typeface="Calibri" charset="0"/>
-                      </a:endParaRPr>
-                    </a:p>
-                  </a:txBody>
-                  <a:tcPr marL="76200" marR="76200" marT="25400" marB="25400" anchor="ctr">
-                    <a:lnL w="12700" cap="flat" cmpd="sng" algn="ctr">
-                      <a:solidFill>
-                        <a:srgbClr val="E4DDCB"/>
-                      </a:solidFill>
-                      <a:prstDash val="solid"/>
-                      <a:round/>
-                      <a:headEnd type="none" w="med" len="med"/>
-                      <a:tailEnd type="none" w="med" len="med"/>
-                    </a:lnL>
-                    <a:lnR w="12700" cap="flat" cmpd="sng" algn="ctr">
-                      <a:solidFill>
-                        <a:srgbClr val="E4DDCB"/>
-                      </a:solidFill>
-                      <a:prstDash val="solid"/>
-                      <a:round/>
-                      <a:headEnd type="none" w="med" len="med"/>
-                      <a:tailEnd type="none" w="med" len="med"/>
-                    </a:lnR>
-                    <a:lnT w="12700" cap="flat" cmpd="sng" algn="ctr">
-                      <a:solidFill>
-                        <a:srgbClr val="E4DDCB"/>
-                      </a:solidFill>
-                      <a:prstDash val="solid"/>
-                      <a:round/>
-                      <a:headEnd type="none" w="med" len="med"/>
-                      <a:tailEnd type="none" w="med" len="med"/>
-                    </a:lnT>
-                    <a:lnB w="12700" cap="flat" cmpd="sng" algn="ctr">
-                      <a:solidFill>
-                        <a:srgbClr val="E4DDCB"/>
-                      </a:solidFill>
-                      <a:prstDash val="solid"/>
-                      <a:round/>
-                      <a:headEnd type="none" w="med" len="med"/>
-                      <a:tailEnd type="none" w="med" len="med"/>
-                    </a:lnB>
-                    <a:solidFill>
-                      <a:srgbClr val="F5F0E4"/>
-                    </a:solidFill>
-                  </a:tcPr>
-                </a:tc>
-                <a:tc>
-                  <a:txBody>
-                    <a:bodyPr/>
-                    <a:lstStyle/>
-                    <a:p>
-                      <a:pPr algn="r" indent="0" marL="0">
-                        <a:buNone/>
-                      </a:pPr>
-                      <a:r>
-                        <a:rPr lang="en-US" sz="1250" dirty="0">
-                          <a:solidFill>
-                            <a:srgbClr val="1B160B"/>
-                          </a:solidFill>
-                          <a:latin typeface="Calibri" pitchFamily="34" charset="0"/>
-                          <a:ea typeface="Calibri" pitchFamily="34" charset="-122"/>
-                          <a:cs typeface="Calibri" pitchFamily="34" charset="-120"/>
-                        </a:rPr>
-                        <a:t>~$467K</a:t>
-                      </a:r>
-                      <a:endParaRPr lang="en-US" sz="1250" dirty="0">
-                        <a:latin typeface="Calibri" charset="0"/>
-                        <a:ea typeface="Calibri" charset="0"/>
-                        <a:cs typeface="Calibri" charset="0"/>
-                      </a:endParaRPr>
-                    </a:p>
-                  </a:txBody>
-                  <a:tcPr marL="76200" marR="76200" marT="25400" marB="25400" anchor="ctr">
-                    <a:lnL w="12700" cap="flat" cmpd="sng" algn="ctr">
-                      <a:solidFill>
-                        <a:srgbClr val="E4DDCB"/>
-                      </a:solidFill>
-                      <a:prstDash val="solid"/>
-                      <a:round/>
-                      <a:headEnd type="none" w="med" len="med"/>
-                      <a:tailEnd type="none" w="med" len="med"/>
-                    </a:lnL>
-                    <a:lnR w="12700" cap="flat" cmpd="sng" algn="ctr">
-                      <a:solidFill>
-                        <a:srgbClr val="E4DDCB"/>
-                      </a:solidFill>
-                      <a:prstDash val="solid"/>
-                      <a:round/>
-                      <a:headEnd type="none" w="med" len="med"/>
-                      <a:tailEnd type="none" w="med" len="med"/>
-                    </a:lnR>
-                    <a:lnT w="12700" cap="flat" cmpd="sng" algn="ctr">
-                      <a:solidFill>
-                        <a:srgbClr val="E4DDCB"/>
-                      </a:solidFill>
-                      <a:prstDash val="solid"/>
-                      <a:round/>
-                      <a:headEnd type="none" w="med" len="med"/>
-                      <a:tailEnd type="none" w="med" len="med"/>
-                    </a:lnT>
-                    <a:lnB w="12700" cap="flat" cmpd="sng" algn="ctr">
-                      <a:solidFill>
-                        <a:srgbClr val="E4DDCB"/>
-                      </a:solidFill>
-                      <a:prstDash val="solid"/>
-                      <a:round/>
-                      <a:headEnd type="none" w="med" len="med"/>
-                      <a:tailEnd type="none" w="med" len="med"/>
-                    </a:lnB>
-                    <a:solidFill>
-                      <a:srgbClr val="F5F0E4"/>
-                    </a:solidFill>
-                  </a:tcPr>
-                </a:tc>
-                <a:tc>
-                  <a:txBody>
-                    <a:bodyPr/>
-                    <a:lstStyle/>
-                    <a:p>
-                      <a:pPr algn="r" indent="0" marL="0">
-                        <a:buNone/>
-                      </a:pPr>
-                      <a:r>
-                        <a:rPr lang="en-US" sz="1250" dirty="0">
-                          <a:solidFill>
-                            <a:srgbClr val="1B160B"/>
-                          </a:solidFill>
-                          <a:latin typeface="Calibri" pitchFamily="34" charset="0"/>
-                          <a:ea typeface="Calibri" pitchFamily="34" charset="-122"/>
-                          <a:cs typeface="Calibri" pitchFamily="34" charset="-120"/>
-                        </a:rPr>
-                        <a:t>—</a:t>
-                      </a:r>
-                      <a:endParaRPr lang="en-US" sz="1250" dirty="0">
-                        <a:latin typeface="Calibri" charset="0"/>
-                        <a:ea typeface="Calibri" charset="0"/>
-                        <a:cs typeface="Calibri" charset="0"/>
-                      </a:endParaRPr>
-                    </a:p>
-                  </a:txBody>
-                  <a:tcPr marL="76200" marR="76200" marT="25400" marB="25400" anchor="ctr">
-                    <a:lnL w="12700" cap="flat" cmpd="sng" algn="ctr">
-                      <a:solidFill>
-                        <a:srgbClr val="E4DDCB"/>
-                      </a:solidFill>
-                      <a:prstDash val="solid"/>
-                      <a:round/>
-                      <a:headEnd type="none" w="med" len="med"/>
-                      <a:tailEnd type="none" w="med" len="med"/>
-                    </a:lnL>
-                    <a:lnR w="12700" cap="flat" cmpd="sng" algn="ctr">
-                      <a:solidFill>
-                        <a:srgbClr val="E4DDCB"/>
-                      </a:solidFill>
-                      <a:prstDash val="solid"/>
-                      <a:round/>
-                      <a:headEnd type="none" w="med" len="med"/>
-                      <a:tailEnd type="none" w="med" len="med"/>
-                    </a:lnR>
-                    <a:lnT w="12700" cap="flat" cmpd="sng" algn="ctr">
-                      <a:solidFill>
-                        <a:srgbClr val="E4DDCB"/>
-                      </a:solidFill>
-                      <a:prstDash val="solid"/>
-                      <a:round/>
-                      <a:headEnd type="none" w="med" len="med"/>
-                      <a:tailEnd type="none" w="med" len="med"/>
-                    </a:lnT>
-                    <a:lnB w="12700" cap="flat" cmpd="sng" algn="ctr">
-                      <a:solidFill>
-                        <a:srgbClr val="E4DDCB"/>
-                      </a:solidFill>
-                      <a:prstDash val="solid"/>
-                      <a:round/>
-                      <a:headEnd type="none" w="med" len="med"/>
-                      <a:tailEnd type="none" w="med" len="med"/>
-                    </a:lnB>
-                    <a:solidFill>
-                      <a:srgbClr val="F5F0E4"/>
-                    </a:solidFill>
-                  </a:tcPr>
-                </a:tc>
-                <a:tc>
-                  <a:txBody>
-                    <a:bodyPr/>
-                    <a:lstStyle/>
-                    <a:p>
-                      <a:pPr algn="r" indent="0" marL="0">
-                        <a:buNone/>
-                      </a:pPr>
-                      <a:r>
-                        <a:rPr lang="en-US" sz="1250" dirty="0">
-                          <a:solidFill>
-                            <a:srgbClr val="1B160B"/>
-                          </a:solidFill>
-                          <a:latin typeface="Calibri" pitchFamily="34" charset="0"/>
-                          <a:ea typeface="Calibri" pitchFamily="34" charset="-122"/>
-                          <a:cs typeface="Calibri" pitchFamily="34" charset="-120"/>
-                        </a:rPr>
-                        <a:t>$26,130</a:t>
-                      </a:r>
-                      <a:endParaRPr lang="en-US" sz="1250" dirty="0">
-                        <a:latin typeface="Calibri" charset="0"/>
-                        <a:ea typeface="Calibri" charset="0"/>
-                        <a:cs typeface="Calibri" charset="0"/>
-                      </a:endParaRPr>
-                    </a:p>
-                  </a:txBody>
-                  <a:tcPr marL="76200" marR="76200" marT="25400" marB="25400" anchor="ctr">
-                    <a:lnL w="12700" cap="flat" cmpd="sng" algn="ctr">
-                      <a:solidFill>
-                        <a:srgbClr val="E4DDCB"/>
-                      </a:solidFill>
-                      <a:prstDash val="solid"/>
-                      <a:round/>
-                      <a:headEnd type="none" w="med" len="med"/>
-                      <a:tailEnd type="none" w="med" len="med"/>
-                    </a:lnL>
-                    <a:lnR w="12700" cap="flat" cmpd="sng" algn="ctr">
-                      <a:solidFill>
-                        <a:srgbClr val="E4DDCB"/>
-                      </a:solidFill>
-                      <a:prstDash val="solid"/>
-                      <a:round/>
-                      <a:headEnd type="none" w="med" len="med"/>
-                      <a:tailEnd type="none" w="med" len="med"/>
-                    </a:lnR>
-                    <a:lnT w="12700" cap="flat" cmpd="sng" algn="ctr">
-                      <a:solidFill>
-                        <a:srgbClr val="E4DDCB"/>
-                      </a:solidFill>
-                      <a:prstDash val="solid"/>
-                      <a:round/>
-                      <a:headEnd type="none" w="med" len="med"/>
-                      <a:tailEnd type="none" w="med" len="med"/>
-                    </a:lnT>
-                    <a:lnB w="12700" cap="flat" cmpd="sng" algn="ctr">
-                      <a:solidFill>
-                        <a:srgbClr val="E4DDCB"/>
-                      </a:solidFill>
-                      <a:prstDash val="solid"/>
-                      <a:round/>
-                      <a:headEnd type="none" w="med" len="med"/>
-                      <a:tailEnd type="none" w="med" len="med"/>
-                    </a:lnB>
-                    <a:solidFill>
-                      <a:srgbClr val="F5F0E4"/>
-                    </a:solidFill>
-                  </a:tcPr>
-                </a:tc>
-                <a:tc>
-                  <a:txBody>
-                    <a:bodyPr/>
-                    <a:lstStyle/>
-                    <a:p>
-                      <a:pPr algn="r" indent="0" marL="0">
-                        <a:buNone/>
-                      </a:pPr>
-                      <a:r>
-                        <a:rPr lang="en-US" sz="1250" dirty="0">
-                          <a:solidFill>
-                            <a:srgbClr val="1B160B"/>
-                          </a:solidFill>
-                          <a:latin typeface="Calibri" pitchFamily="34" charset="0"/>
-                          <a:ea typeface="Calibri" pitchFamily="34" charset="-122"/>
-                          <a:cs typeface="Calibri" pitchFamily="34" charset="-120"/>
-                        </a:rPr>
-                        <a:t>~$274,782</a:t>
-                      </a:r>
-                      <a:endParaRPr lang="en-US" sz="1250" dirty="0">
-                        <a:latin typeface="Calibri" charset="0"/>
-                        <a:ea typeface="Calibri" charset="0"/>
-                        <a:cs typeface="Calibri" charset="0"/>
-                      </a:endParaRPr>
-                    </a:p>
-                  </a:txBody>
-                  <a:tcPr marL="76200" marR="76200" marT="25400" marB="25400" anchor="ctr">
-                    <a:lnL w="12700" cap="flat" cmpd="sng" algn="ctr">
-                      <a:solidFill>
-                        <a:srgbClr val="E4DDCB"/>
-                      </a:solidFill>
-                      <a:prstDash val="solid"/>
-                      <a:round/>
-                      <a:headEnd type="none" w="med" len="med"/>
-                      <a:tailEnd type="none" w="med" len="med"/>
-                    </a:lnL>
-                    <a:lnR w="12700" cap="flat" cmpd="sng" algn="ctr">
-                      <a:solidFill>
-                        <a:srgbClr val="E4DDCB"/>
-                      </a:solidFill>
-                      <a:prstDash val="solid"/>
-                      <a:round/>
-                      <a:headEnd type="none" w="med" len="med"/>
-                      <a:tailEnd type="none" w="med" len="med"/>
-                    </a:lnR>
-                    <a:lnT w="12700" cap="flat" cmpd="sng" algn="ctr">
-                      <a:solidFill>
-                        <a:srgbClr val="E4DDCB"/>
-                      </a:solidFill>
-                      <a:prstDash val="solid"/>
-                      <a:round/>
-                      <a:headEnd type="none" w="med" len="med"/>
-                      <a:tailEnd type="none" w="med" len="med"/>
-                    </a:lnT>
-                    <a:lnB w="12700" cap="flat" cmpd="sng" algn="ctr">
-                      <a:solidFill>
-                        <a:srgbClr val="E4DDCB"/>
-                      </a:solidFill>
-                      <a:prstDash val="solid"/>
-                      <a:round/>
-                      <a:headEnd type="none" w="med" len="med"/>
-                      <a:tailEnd type="none" w="med" len="med"/>
-                    </a:lnB>
-                    <a:solidFill>
-                      <a:srgbClr val="F5F0E4"/>
-                    </a:solidFill>
-                  </a:tcPr>
-                </a:tc>
-                <a:tc>
-                  <a:txBody>
-                    <a:bodyPr/>
-                    <a:lstStyle/>
-                    <a:p>
-                      <a:pPr algn="r" indent="0" marL="0">
-                        <a:buNone/>
-                      </a:pPr>
-                      <a:r>
-                        <a:rPr lang="en-US" sz="1250" dirty="0">
-                          <a:solidFill>
-                            <a:srgbClr val="1B160B"/>
-                          </a:solidFill>
-                          <a:latin typeface="Calibri" pitchFamily="34" charset="0"/>
-                          <a:ea typeface="Calibri" pitchFamily="34" charset="-122"/>
-                          <a:cs typeface="Calibri" pitchFamily="34" charset="-120"/>
-                        </a:rPr>
-                        <a:t>~1,052%</a:t>
-                      </a:r>
-                      <a:endParaRPr lang="en-US" sz="1250" dirty="0">
-                        <a:latin typeface="Calibri" charset="0"/>
-                        <a:ea typeface="Calibri" charset="0"/>
-                        <a:cs typeface="Calibri" charset="0"/>
-                      </a:endParaRPr>
-                    </a:p>
-                  </a:txBody>
-                  <a:tcPr marL="76200" marR="76200" marT="25400" marB="25400" anchor="ctr">
-                    <a:lnL w="12700" cap="flat" cmpd="sng" algn="ctr">
-                      <a:solidFill>
-                        <a:srgbClr val="E4DDCB"/>
-                      </a:solidFill>
-                      <a:prstDash val="solid"/>
-                      <a:round/>
-                      <a:headEnd type="none" w="med" len="med"/>
-                      <a:tailEnd type="none" w="med" len="med"/>
-                    </a:lnL>
-                    <a:lnR w="12700" cap="flat" cmpd="sng" algn="ctr">
-                      <a:solidFill>
-                        <a:srgbClr val="E4DDCB"/>
-                      </a:solidFill>
-                      <a:prstDash val="solid"/>
-                      <a:round/>
-                      <a:headEnd type="none" w="med" len="med"/>
-                      <a:tailEnd type="none" w="med" len="med"/>
-                    </a:lnR>
-                    <a:lnT w="12700" cap="flat" cmpd="sng" algn="ctr">
-                      <a:solidFill>
-                        <a:srgbClr val="E4DDCB"/>
-                      </a:solidFill>
-                      <a:prstDash val="solid"/>
-                      <a:round/>
-                      <a:headEnd type="none" w="med" len="med"/>
-                      <a:tailEnd type="none" w="med" len="med"/>
-                    </a:lnT>
-                    <a:lnB w="12700" cap="flat" cmpd="sng" algn="ctr">
-                      <a:solidFill>
-                        <a:srgbClr val="E4DDCB"/>
-                      </a:solidFill>
-                      <a:prstDash val="solid"/>
-                      <a:round/>
-                      <a:headEnd type="none" w="med" len="med"/>
-                      <a:tailEnd type="none" w="med" len="med"/>
-                    </a:lnB>
-                    <a:solidFill>
-                      <a:srgbClr val="F5F0E4"/>
-                    </a:solidFill>
-                  </a:tcPr>
-                </a:tc>
-              </a:tr>
-              <a:tr h="457200">
+              <a:tr h="512064">
                 <a:tc>
                   <a:txBody>
                     <a:bodyPr/>

</xml_diff>

<commit_message>
Rework Downside Protection slide into a conversion funnel
Replaces the capture-rate stress test with an ad-spend -> leads generated
-> leads captured -> leads converted funnel:
- Ad spend $36,660 -> ~470 leads ($78/lead) -> ~188 captured (40%) ->
  29.8 listings converted (16%)
- Downside callout: ~2.4 listings cover the full spend (8% of output);
  covered 3x over even if capture and conversion both halve; ~12x cushion
- Funnel rates flagged as modeled assumptions

Co-Authored-By: Claude Opus 4.8 <noreply@anthropic.com>
Claude-Session: https://claude.ai/code/session_01Cyq3zkcaFRihnz3XVtX9JE
</commit_message>
<xml_diff>
--- a/presentations/Geo-Farming-Campaign.pptx
+++ b/presentations/Geo-Farming-Campaign.pptx
@@ -4359,7 +4359,7 @@
                 <a:ea typeface="Cambria" pitchFamily="34" charset="-122"/>
                 <a:cs typeface="Cambria" pitchFamily="34" charset="-120"/>
               </a:rPr>
-              <a:t>Stress-tested: profitable at a third of the plan.</a:t>
+              <a:t>The funnel clears its cost many times over.</a:t>
             </a:r>
             <a:endParaRPr lang="en-US" sz="3100" dirty="0"/>
           </a:p>
@@ -4401,7 +4401,7 @@
                 <a:ea typeface="Calibri" pitchFamily="34" charset="-122"/>
                 <a:cs typeface="Calibri" pitchFamily="34" charset="-120"/>
               </a:rPr>
-              <a:t>Cut the 15% capture assumption to a third — 5% — and the portfolio still nets +$113,981. The mail spend is fixed and small; there is no realistic capture rate where this loses money.</a:t>
+              <a:t>Ad spend is fixed and small. Lead generation, capture, and conversion could all come in soft and the campaign still pays for itself — here's the funnel, and how little of it break-even actually requires.</a:t>
             </a:r>
             <a:endParaRPr lang="en-US" sz="1450" dirty="0"/>
           </a:p>
@@ -4409,64 +4409,76 @@
       </p:sp>
       <p:sp>
         <p:nvSpPr>
-          <p:cNvPr id="5" name="Text 3"/>
-          <p:cNvSpPr/>
-          <p:nvPr/>
-        </p:nvSpPr>
-        <p:spPr>
-          <a:xfrm>
-            <a:off x="640080" y="2898648"/>
-            <a:ext cx="3291840" cy="475488"/>
-          </a:xfrm>
-          <a:prstGeom prst="rect">
-            <a:avLst/>
-          </a:prstGeom>
-          <a:noFill/>
-          <a:ln/>
-        </p:spPr>
-        <p:txBody>
-          <a:bodyPr wrap="square" rtlCol="0" anchor="ctr"/>
-          <a:lstStyle/>
-          <a:p>
-            <a:pPr algn="r" indent="0" marL="0">
-              <a:buNone/>
-            </a:pPr>
-            <a:r>
-              <a:rPr lang="en-US" sz="1250" dirty="0">
-                <a:solidFill>
-                  <a:srgbClr val="4A4436"/>
-                </a:solidFill>
-                <a:latin typeface="Calibri" pitchFamily="34" charset="0"/>
-                <a:ea typeface="Calibri" pitchFamily="34" charset="-122"/>
-                <a:cs typeface="Calibri" pitchFamily="34" charset="-120"/>
-              </a:rPr>
-              <a:t>Plan · 15% capture</a:t>
-            </a:r>
-            <a:endParaRPr lang="en-US" sz="1250" dirty="0"/>
-          </a:p>
-        </p:txBody>
-      </p:sp>
-      <p:sp>
-        <p:nvSpPr>
-          <p:cNvPr id="6" name="Shape 4"/>
-          <p:cNvSpPr/>
-          <p:nvPr/>
-        </p:nvSpPr>
-        <p:spPr>
-          <a:xfrm>
-            <a:off x="4114800" y="2926080"/>
-            <a:ext cx="5623560" cy="420624"/>
+          <p:cNvPr id="5" name="Shape 3"/>
+          <p:cNvSpPr/>
+          <p:nvPr/>
+        </p:nvSpPr>
+        <p:spPr>
+          <a:xfrm>
+            <a:off x="640080" y="2286000"/>
+            <a:ext cx="2468880" cy="2148840"/>
           </a:xfrm>
           <a:prstGeom prst="roundRect">
             <a:avLst>
-              <a:gd name="adj" fmla="val 9783"/>
+              <a:gd name="adj" fmla="val 3404"/>
             </a:avLst>
           </a:prstGeom>
           <a:solidFill>
-            <a:srgbClr val="2A6FC4"/>
+            <a:srgbClr val="FBFAF6"/>
           </a:solidFill>
-          <a:ln/>
-        </p:spPr>
+          <a:ln w="12700">
+            <a:solidFill>
+              <a:srgbClr val="E4DDCB"/>
+            </a:solidFill>
+            <a:prstDash val="solid"/>
+          </a:ln>
+          <a:effectLst>
+            <a:outerShdw sx="100000" sy="100000" kx="0" ky="0" algn="bl" rotWithShape="0" blurRad="114300" dist="38100" dir="5400000">
+              <a:srgbClr val="6B5A2A">
+                <a:alpha val="18000"/>
+              </a:srgbClr>
+            </a:outerShdw>
+          </a:effectLst>
+        </p:spPr>
+      </p:sp>
+      <p:sp>
+        <p:nvSpPr>
+          <p:cNvPr id="6" name="Text 4"/>
+          <p:cNvSpPr/>
+          <p:nvPr/>
+        </p:nvSpPr>
+        <p:spPr>
+          <a:xfrm>
+            <a:off x="777240" y="2651760"/>
+            <a:ext cx="2194560" cy="731520"/>
+          </a:xfrm>
+          <a:prstGeom prst="rect">
+            <a:avLst/>
+          </a:prstGeom>
+          <a:noFill/>
+          <a:ln/>
+        </p:spPr>
+        <p:txBody>
+          <a:bodyPr wrap="square" rtlCol="0" anchor="ctr"/>
+          <a:lstStyle/>
+          <a:p>
+            <a:pPr algn="ctr" indent="0" marL="0">
+              <a:buNone/>
+            </a:pPr>
+            <a:r>
+              <a:rPr lang="en-US" sz="3600" b="1" dirty="0">
+                <a:solidFill>
+                  <a:srgbClr val="8A6A1E"/>
+                </a:solidFill>
+                <a:latin typeface="Cambria" pitchFamily="34" charset="0"/>
+                <a:ea typeface="Cambria" pitchFamily="34" charset="-122"/>
+                <a:cs typeface="Cambria" pitchFamily="34" charset="-120"/>
+              </a:rPr>
+              <a:t>$36,660</a:t>
+            </a:r>
+            <a:endParaRPr lang="en-US" sz="3600" dirty="0"/>
+          </a:p>
+        </p:txBody>
       </p:sp>
       <p:sp>
         <p:nvSpPr>
@@ -4476,34 +4488,34 @@
         </p:nvSpPr>
         <p:spPr>
           <a:xfrm>
-            <a:off x="9866376" y="2898648"/>
-            <a:ext cx="1783080" cy="475488"/>
-          </a:xfrm>
-          <a:prstGeom prst="rect">
-            <a:avLst/>
-          </a:prstGeom>
-          <a:noFill/>
-          <a:ln/>
-        </p:spPr>
-        <p:txBody>
-          <a:bodyPr wrap="square" rtlCol="0" anchor="ctr"/>
-          <a:lstStyle/>
-          <a:p>
-            <a:pPr algn="l" indent="0" marL="0">
-              <a:buNone/>
-            </a:pPr>
-            <a:r>
-              <a:rPr lang="en-US" sz="1300" b="1" dirty="0">
-                <a:solidFill>
-                  <a:srgbClr val="1E7A44"/>
-                </a:solidFill>
-                <a:latin typeface="Calibri" pitchFamily="34" charset="0"/>
-                <a:ea typeface="Calibri" pitchFamily="34" charset="-122"/>
-                <a:cs typeface="Calibri" pitchFamily="34" charset="-120"/>
-              </a:rPr>
-              <a:t>+$415,263</a:t>
-            </a:r>
-            <a:endParaRPr lang="en-US" sz="1300" dirty="0"/>
+            <a:off x="777240" y="3520440"/>
+            <a:ext cx="2194560" cy="274320"/>
+          </a:xfrm>
+          <a:prstGeom prst="rect">
+            <a:avLst/>
+          </a:prstGeom>
+          <a:noFill/>
+          <a:ln/>
+        </p:spPr>
+        <p:txBody>
+          <a:bodyPr wrap="square" rtlCol="0" anchor="ctr"/>
+          <a:lstStyle/>
+          <a:p>
+            <a:pPr algn="ctr" indent="0" marL="0">
+              <a:buNone/>
+            </a:pPr>
+            <a:r>
+              <a:rPr lang="en-US" sz="1050" b="1" spc="60" kern="0" dirty="0">
+                <a:solidFill>
+                  <a:srgbClr val="8A8272"/>
+                </a:solidFill>
+                <a:latin typeface="Calibri" pitchFamily="34" charset="0"/>
+                <a:ea typeface="Calibri" pitchFamily="34" charset="-122"/>
+                <a:cs typeface="Calibri" pitchFamily="34" charset="-120"/>
+              </a:rPr>
+              <a:t>AD SPEND</a:t>
+            </a:r>
+            <a:endParaRPr lang="en-US" sz="1050" dirty="0"/>
           </a:p>
         </p:txBody>
       </p:sp>
@@ -4515,327 +4527,27 @@
         </p:nvSpPr>
         <p:spPr>
           <a:xfrm>
-            <a:off x="640080" y="3630168"/>
-            <a:ext cx="3291840" cy="475488"/>
-          </a:xfrm>
-          <a:prstGeom prst="rect">
-            <a:avLst/>
-          </a:prstGeom>
-          <a:noFill/>
-          <a:ln/>
-        </p:spPr>
-        <p:txBody>
-          <a:bodyPr wrap="square" rtlCol="0" anchor="ctr"/>
-          <a:lstStyle/>
-          <a:p>
-            <a:pPr algn="r" indent="0" marL="0">
-              <a:buNone/>
-            </a:pPr>
-            <a:r>
-              <a:rPr lang="en-US" sz="1250" dirty="0">
-                <a:solidFill>
-                  <a:srgbClr val="4A4436"/>
-                </a:solidFill>
-                <a:latin typeface="Calibri" pitchFamily="34" charset="0"/>
-                <a:ea typeface="Calibri" pitchFamily="34" charset="-122"/>
-                <a:cs typeface="Calibri" pitchFamily="34" charset="-120"/>
-              </a:rPr>
-              <a:t>10% capture</a:t>
-            </a:r>
-            <a:endParaRPr lang="en-US" sz="1250" dirty="0"/>
-          </a:p>
-        </p:txBody>
-      </p:sp>
-      <p:sp>
-        <p:nvSpPr>
-          <p:cNvPr id="9" name="Shape 7"/>
-          <p:cNvSpPr/>
-          <p:nvPr/>
-        </p:nvSpPr>
-        <p:spPr>
-          <a:xfrm>
-            <a:off x="4114800" y="3657600"/>
-            <a:ext cx="3583555" cy="420624"/>
-          </a:xfrm>
-          <a:prstGeom prst="roundRect">
-            <a:avLst>
-              <a:gd name="adj" fmla="val 9783"/>
-            </a:avLst>
-          </a:prstGeom>
-          <a:solidFill>
-            <a:srgbClr val="2A6FC4"/>
-          </a:solidFill>
-          <a:ln/>
-        </p:spPr>
-      </p:sp>
-      <p:sp>
-        <p:nvSpPr>
-          <p:cNvPr id="10" name="Text 8"/>
-          <p:cNvSpPr/>
-          <p:nvPr/>
-        </p:nvSpPr>
-        <p:spPr>
-          <a:xfrm>
-            <a:off x="7826371" y="3630168"/>
-            <a:ext cx="1783080" cy="475488"/>
-          </a:xfrm>
-          <a:prstGeom prst="rect">
-            <a:avLst/>
-          </a:prstGeom>
-          <a:noFill/>
-          <a:ln/>
-        </p:spPr>
-        <p:txBody>
-          <a:bodyPr wrap="square" rtlCol="0" anchor="ctr"/>
-          <a:lstStyle/>
-          <a:p>
-            <a:pPr algn="l" indent="0" marL="0">
-              <a:buNone/>
-            </a:pPr>
-            <a:r>
-              <a:rPr lang="en-US" sz="1300" b="1" dirty="0">
-                <a:solidFill>
-                  <a:srgbClr val="1B160B"/>
-                </a:solidFill>
-                <a:latin typeface="Calibri" pitchFamily="34" charset="0"/>
-                <a:ea typeface="Calibri" pitchFamily="34" charset="-122"/>
-                <a:cs typeface="Calibri" pitchFamily="34" charset="-120"/>
-              </a:rPr>
-              <a:t>+$264,622</a:t>
-            </a:r>
-            <a:endParaRPr lang="en-US" sz="1300" dirty="0"/>
-          </a:p>
-        </p:txBody>
-      </p:sp>
-      <p:sp>
-        <p:nvSpPr>
-          <p:cNvPr id="11" name="Text 9"/>
-          <p:cNvSpPr/>
-          <p:nvPr/>
-        </p:nvSpPr>
-        <p:spPr>
-          <a:xfrm>
-            <a:off x="640080" y="4361688"/>
-            <a:ext cx="3291840" cy="475488"/>
-          </a:xfrm>
-          <a:prstGeom prst="rect">
-            <a:avLst/>
-          </a:prstGeom>
-          <a:noFill/>
-          <a:ln/>
-        </p:spPr>
-        <p:txBody>
-          <a:bodyPr wrap="square" rtlCol="0" anchor="ctr"/>
-          <a:lstStyle/>
-          <a:p>
-            <a:pPr algn="r" indent="0" marL="0">
-              <a:buNone/>
-            </a:pPr>
-            <a:r>
-              <a:rPr lang="en-US" sz="1250" dirty="0">
-                <a:solidFill>
-                  <a:srgbClr val="4A4436"/>
-                </a:solidFill>
-                <a:latin typeface="Calibri" pitchFamily="34" charset="0"/>
-                <a:ea typeface="Calibri" pitchFamily="34" charset="-122"/>
-                <a:cs typeface="Calibri" pitchFamily="34" charset="-120"/>
-              </a:rPr>
-              <a:t>7.5% capture</a:t>
-            </a:r>
-            <a:endParaRPr lang="en-US" sz="1250" dirty="0"/>
-          </a:p>
-        </p:txBody>
-      </p:sp>
-      <p:sp>
-        <p:nvSpPr>
-          <p:cNvPr id="12" name="Shape 10"/>
-          <p:cNvSpPr/>
-          <p:nvPr/>
-        </p:nvSpPr>
-        <p:spPr>
-          <a:xfrm>
-            <a:off x="4114800" y="4389120"/>
-            <a:ext cx="2563559" cy="420624"/>
-          </a:xfrm>
-          <a:prstGeom prst="roundRect">
-            <a:avLst>
-              <a:gd name="adj" fmla="val 9783"/>
-            </a:avLst>
-          </a:prstGeom>
-          <a:solidFill>
-            <a:srgbClr val="2A6FC4"/>
-          </a:solidFill>
-          <a:ln/>
-        </p:spPr>
-      </p:sp>
-      <p:sp>
-        <p:nvSpPr>
-          <p:cNvPr id="13" name="Text 11"/>
-          <p:cNvSpPr/>
-          <p:nvPr/>
-        </p:nvSpPr>
-        <p:spPr>
-          <a:xfrm>
-            <a:off x="6806375" y="4361688"/>
-            <a:ext cx="1783080" cy="475488"/>
-          </a:xfrm>
-          <a:prstGeom prst="rect">
-            <a:avLst/>
-          </a:prstGeom>
-          <a:noFill/>
-          <a:ln/>
-        </p:spPr>
-        <p:txBody>
-          <a:bodyPr wrap="square" rtlCol="0" anchor="ctr"/>
-          <a:lstStyle/>
-          <a:p>
-            <a:pPr algn="l" indent="0" marL="0">
-              <a:buNone/>
-            </a:pPr>
-            <a:r>
-              <a:rPr lang="en-US" sz="1300" b="1" dirty="0">
-                <a:solidFill>
-                  <a:srgbClr val="1B160B"/>
-                </a:solidFill>
-                <a:latin typeface="Calibri" pitchFamily="34" charset="0"/>
-                <a:ea typeface="Calibri" pitchFamily="34" charset="-122"/>
-                <a:cs typeface="Calibri" pitchFamily="34" charset="-120"/>
-              </a:rPr>
-              <a:t>+$189,302</a:t>
-            </a:r>
-            <a:endParaRPr lang="en-US" sz="1300" dirty="0"/>
-          </a:p>
-        </p:txBody>
-      </p:sp>
-      <p:sp>
-        <p:nvSpPr>
-          <p:cNvPr id="14" name="Text 12"/>
-          <p:cNvSpPr/>
-          <p:nvPr/>
-        </p:nvSpPr>
-        <p:spPr>
-          <a:xfrm>
-            <a:off x="640080" y="5093208"/>
-            <a:ext cx="3291840" cy="475488"/>
-          </a:xfrm>
-          <a:prstGeom prst="rect">
-            <a:avLst/>
-          </a:prstGeom>
-          <a:noFill/>
-          <a:ln/>
-        </p:spPr>
-        <p:txBody>
-          <a:bodyPr wrap="square" rtlCol="0" anchor="ctr"/>
-          <a:lstStyle/>
-          <a:p>
-            <a:pPr algn="r" indent="0" marL="0">
-              <a:buNone/>
-            </a:pPr>
-            <a:r>
-              <a:rPr lang="en-US" sz="1250" dirty="0">
-                <a:solidFill>
-                  <a:srgbClr val="4A4436"/>
-                </a:solidFill>
-                <a:latin typeface="Calibri" pitchFamily="34" charset="0"/>
-                <a:ea typeface="Calibri" pitchFamily="34" charset="-122"/>
-                <a:cs typeface="Calibri" pitchFamily="34" charset="-120"/>
-              </a:rPr>
-              <a:t>5% capture  (⅓ of plan)</a:t>
-            </a:r>
-            <a:endParaRPr lang="en-US" sz="1250" dirty="0"/>
-          </a:p>
-        </p:txBody>
-      </p:sp>
-      <p:sp>
-        <p:nvSpPr>
-          <p:cNvPr id="15" name="Shape 13"/>
-          <p:cNvSpPr/>
-          <p:nvPr/>
-        </p:nvSpPr>
-        <p:spPr>
-          <a:xfrm>
-            <a:off x="4114800" y="5120640"/>
-            <a:ext cx="1543549" cy="420624"/>
-          </a:xfrm>
-          <a:prstGeom prst="roundRect">
-            <a:avLst>
-              <a:gd name="adj" fmla="val 9783"/>
-            </a:avLst>
-          </a:prstGeom>
-          <a:solidFill>
-            <a:srgbClr val="2A6FC4"/>
-          </a:solidFill>
-          <a:ln/>
-        </p:spPr>
-      </p:sp>
-      <p:sp>
-        <p:nvSpPr>
-          <p:cNvPr id="16" name="Text 14"/>
-          <p:cNvSpPr/>
-          <p:nvPr/>
-        </p:nvSpPr>
-        <p:spPr>
-          <a:xfrm>
-            <a:off x="5786365" y="5093208"/>
-            <a:ext cx="1783080" cy="475488"/>
-          </a:xfrm>
-          <a:prstGeom prst="rect">
-            <a:avLst/>
-          </a:prstGeom>
-          <a:noFill/>
-          <a:ln/>
-        </p:spPr>
-        <p:txBody>
-          <a:bodyPr wrap="square" rtlCol="0" anchor="ctr"/>
-          <a:lstStyle/>
-          <a:p>
-            <a:pPr algn="l" indent="0" marL="0">
-              <a:buNone/>
-            </a:pPr>
-            <a:r>
-              <a:rPr lang="en-US" sz="1300" b="1" dirty="0">
-                <a:solidFill>
-                  <a:srgbClr val="1B160B"/>
-                </a:solidFill>
-                <a:latin typeface="Calibri" pitchFamily="34" charset="0"/>
-                <a:ea typeface="Calibri" pitchFamily="34" charset="-122"/>
-                <a:cs typeface="Calibri" pitchFamily="34" charset="-120"/>
-              </a:rPr>
-              <a:t>+$113,981</a:t>
-            </a:r>
-            <a:endParaRPr lang="en-US" sz="1300" dirty="0"/>
-          </a:p>
-        </p:txBody>
-      </p:sp>
-      <p:sp>
-        <p:nvSpPr>
-          <p:cNvPr id="17" name="Text 15"/>
-          <p:cNvSpPr/>
-          <p:nvPr/>
-        </p:nvSpPr>
-        <p:spPr>
-          <a:xfrm>
-            <a:off x="640080" y="5943600"/>
-            <a:ext cx="10881360" cy="457200"/>
-          </a:xfrm>
-          <a:prstGeom prst="rect">
-            <a:avLst/>
-          </a:prstGeom>
-          <a:noFill/>
-          <a:ln/>
-        </p:spPr>
-        <p:txBody>
-          <a:bodyPr wrap="square" rtlCol="0" anchor="ctr"/>
-          <a:lstStyle/>
-          <a:p>
-            <a:pPr algn="l" indent="0" marL="0">
+            <a:off x="731520" y="3822192"/>
+            <a:ext cx="2286000" cy="457200"/>
+          </a:xfrm>
+          <a:prstGeom prst="rect">
+            <a:avLst/>
+          </a:prstGeom>
+          <a:noFill/>
+          <a:ln/>
+        </p:spPr>
+        <p:txBody>
+          <a:bodyPr wrap="square" rtlCol="0" anchor="ctr"/>
+          <a:lstStyle/>
+          <a:p>
+            <a:pPr algn="ctr" indent="0" marL="0">
               <a:lnSpc>
                 <a:spcPct val="100000"/>
               </a:lnSpc>
               <a:buNone/>
             </a:pPr>
             <a:r>
-              <a:rPr lang="en-US" sz="1150" b="1" dirty="0">
+              <a:rPr lang="en-US" sz="1100" dirty="0">
                 <a:solidFill>
                   <a:srgbClr val="4A4436"/>
                 </a:solidFill>
@@ -4843,16 +4555,343 @@
                 <a:ea typeface="Calibri" pitchFamily="34" charset="-122"/>
                 <a:cs typeface="Calibri" pitchFamily="34" charset="-120"/>
               </a:rPr>
-              <a:t>Break-even capture is around 1%</a:t>
-            </a:r>
-            <a:pPr algn="l" indent="0" marL="0">
+              <a:t>$3,055 per month</a:t>
+            </a:r>
+            <a:endParaRPr lang="en-US" sz="1100" dirty="0"/>
+          </a:p>
+        </p:txBody>
+      </p:sp>
+      <p:sp>
+        <p:nvSpPr>
+          <p:cNvPr id="9" name="Text 7"/>
+          <p:cNvSpPr/>
+          <p:nvPr/>
+        </p:nvSpPr>
+        <p:spPr>
+          <a:xfrm>
+            <a:off x="3035808" y="2880360"/>
+            <a:ext cx="457200" cy="457200"/>
+          </a:xfrm>
+          <a:prstGeom prst="rect">
+            <a:avLst/>
+          </a:prstGeom>
+          <a:noFill/>
+          <a:ln/>
+        </p:spPr>
+        <p:txBody>
+          <a:bodyPr wrap="square" rtlCol="0" anchor="ctr"/>
+          <a:lstStyle/>
+          <a:p>
+            <a:pPr algn="ctr" indent="0" marL="0">
+              <a:buNone/>
+            </a:pPr>
+            <a:r>
+              <a:rPr lang="en-US" sz="2200" b="1" dirty="0">
+                <a:solidFill>
+                  <a:srgbClr val="B0842F"/>
+                </a:solidFill>
+                <a:latin typeface="Calibri" pitchFamily="34" charset="0"/>
+                <a:ea typeface="Calibri" pitchFamily="34" charset="-122"/>
+                <a:cs typeface="Calibri" pitchFamily="34" charset="-120"/>
+              </a:rPr>
+              <a:t>→</a:t>
+            </a:r>
+            <a:endParaRPr lang="en-US" sz="2200" dirty="0"/>
+          </a:p>
+        </p:txBody>
+      </p:sp>
+      <p:sp>
+        <p:nvSpPr>
+          <p:cNvPr id="10" name="Shape 8"/>
+          <p:cNvSpPr/>
+          <p:nvPr/>
+        </p:nvSpPr>
+        <p:spPr>
+          <a:xfrm>
+            <a:off x="3383280" y="2286000"/>
+            <a:ext cx="2468880" cy="2148840"/>
+          </a:xfrm>
+          <a:prstGeom prst="roundRect">
+            <a:avLst>
+              <a:gd name="adj" fmla="val 3404"/>
+            </a:avLst>
+          </a:prstGeom>
+          <a:solidFill>
+            <a:srgbClr val="FBFAF6"/>
+          </a:solidFill>
+          <a:ln w="12700">
+            <a:solidFill>
+              <a:srgbClr val="E4DDCB"/>
+            </a:solidFill>
+            <a:prstDash val="solid"/>
+          </a:ln>
+          <a:effectLst>
+            <a:outerShdw sx="100000" sy="100000" kx="0" ky="0" algn="bl" rotWithShape="0" blurRad="114300" dist="38100" dir="5400000">
+              <a:srgbClr val="6B5A2A">
+                <a:alpha val="18000"/>
+              </a:srgbClr>
+            </a:outerShdw>
+          </a:effectLst>
+        </p:spPr>
+      </p:sp>
+      <p:sp>
+        <p:nvSpPr>
+          <p:cNvPr id="11" name="Text 9"/>
+          <p:cNvSpPr/>
+          <p:nvPr/>
+        </p:nvSpPr>
+        <p:spPr>
+          <a:xfrm>
+            <a:off x="3520440" y="2651760"/>
+            <a:ext cx="2194560" cy="731520"/>
+          </a:xfrm>
+          <a:prstGeom prst="rect">
+            <a:avLst/>
+          </a:prstGeom>
+          <a:noFill/>
+          <a:ln/>
+        </p:spPr>
+        <p:txBody>
+          <a:bodyPr wrap="square" rtlCol="0" anchor="ctr"/>
+          <a:lstStyle/>
+          <a:p>
+            <a:pPr algn="ctr" indent="0" marL="0">
+              <a:buNone/>
+            </a:pPr>
+            <a:r>
+              <a:rPr lang="en-US" sz="3600" b="1" dirty="0">
+                <a:solidFill>
+                  <a:srgbClr val="1B160B"/>
+                </a:solidFill>
+                <a:latin typeface="Cambria" pitchFamily="34" charset="0"/>
+                <a:ea typeface="Cambria" pitchFamily="34" charset="-122"/>
+                <a:cs typeface="Cambria" pitchFamily="34" charset="-120"/>
+              </a:rPr>
+              <a:t>~470</a:t>
+            </a:r>
+            <a:endParaRPr lang="en-US" sz="3600" dirty="0"/>
+          </a:p>
+        </p:txBody>
+      </p:sp>
+      <p:sp>
+        <p:nvSpPr>
+          <p:cNvPr id="12" name="Text 10"/>
+          <p:cNvSpPr/>
+          <p:nvPr/>
+        </p:nvSpPr>
+        <p:spPr>
+          <a:xfrm>
+            <a:off x="3520440" y="3520440"/>
+            <a:ext cx="2194560" cy="274320"/>
+          </a:xfrm>
+          <a:prstGeom prst="rect">
+            <a:avLst/>
+          </a:prstGeom>
+          <a:noFill/>
+          <a:ln/>
+        </p:spPr>
+        <p:txBody>
+          <a:bodyPr wrap="square" rtlCol="0" anchor="ctr"/>
+          <a:lstStyle/>
+          <a:p>
+            <a:pPr algn="ctr" indent="0" marL="0">
+              <a:buNone/>
+            </a:pPr>
+            <a:r>
+              <a:rPr lang="en-US" sz="1050" b="1" spc="60" kern="0" dirty="0">
+                <a:solidFill>
+                  <a:srgbClr val="8A8272"/>
+                </a:solidFill>
+                <a:latin typeface="Calibri" pitchFamily="34" charset="0"/>
+                <a:ea typeface="Calibri" pitchFamily="34" charset="-122"/>
+                <a:cs typeface="Calibri" pitchFamily="34" charset="-120"/>
+              </a:rPr>
+              <a:t>LEADS GENERATED</a:t>
+            </a:r>
+            <a:endParaRPr lang="en-US" sz="1050" dirty="0"/>
+          </a:p>
+        </p:txBody>
+      </p:sp>
+      <p:sp>
+        <p:nvSpPr>
+          <p:cNvPr id="13" name="Text 11"/>
+          <p:cNvSpPr/>
+          <p:nvPr/>
+        </p:nvSpPr>
+        <p:spPr>
+          <a:xfrm>
+            <a:off x="3474720" y="3822192"/>
+            <a:ext cx="2286000" cy="457200"/>
+          </a:xfrm>
+          <a:prstGeom prst="rect">
+            <a:avLst/>
+          </a:prstGeom>
+          <a:noFill/>
+          <a:ln/>
+        </p:spPr>
+        <p:txBody>
+          <a:bodyPr wrap="square" rtlCol="0" anchor="ctr"/>
+          <a:lstStyle/>
+          <a:p>
+            <a:pPr algn="ctr" indent="0" marL="0">
               <a:lnSpc>
                 <a:spcPct val="100000"/>
               </a:lnSpc>
               <a:buNone/>
             </a:pPr>
             <a:r>
-              <a:rPr lang="en-US" sz="1150" dirty="0">
+              <a:rPr lang="en-US" sz="1100" dirty="0">
+                <a:solidFill>
+                  <a:srgbClr val="4A4436"/>
+                </a:solidFill>
+                <a:latin typeface="Calibri" pitchFamily="34" charset="0"/>
+                <a:ea typeface="Calibri" pitchFamily="34" charset="-122"/>
+                <a:cs typeface="Calibri" pitchFamily="34" charset="-120"/>
+              </a:rPr>
+              <a:t>$78 per lead</a:t>
+            </a:r>
+            <a:endParaRPr lang="en-US" sz="1100" dirty="0"/>
+          </a:p>
+        </p:txBody>
+      </p:sp>
+      <p:sp>
+        <p:nvSpPr>
+          <p:cNvPr id="14" name="Text 12"/>
+          <p:cNvSpPr/>
+          <p:nvPr/>
+        </p:nvSpPr>
+        <p:spPr>
+          <a:xfrm>
+            <a:off x="5779008" y="2880360"/>
+            <a:ext cx="457200" cy="457200"/>
+          </a:xfrm>
+          <a:prstGeom prst="rect">
+            <a:avLst/>
+          </a:prstGeom>
+          <a:noFill/>
+          <a:ln/>
+        </p:spPr>
+        <p:txBody>
+          <a:bodyPr wrap="square" rtlCol="0" anchor="ctr"/>
+          <a:lstStyle/>
+          <a:p>
+            <a:pPr algn="ctr" indent="0" marL="0">
+              <a:buNone/>
+            </a:pPr>
+            <a:r>
+              <a:rPr lang="en-US" sz="2200" b="1" dirty="0">
+                <a:solidFill>
+                  <a:srgbClr val="B0842F"/>
+                </a:solidFill>
+                <a:latin typeface="Calibri" pitchFamily="34" charset="0"/>
+                <a:ea typeface="Calibri" pitchFamily="34" charset="-122"/>
+                <a:cs typeface="Calibri" pitchFamily="34" charset="-120"/>
+              </a:rPr>
+              <a:t>→</a:t>
+            </a:r>
+            <a:endParaRPr lang="en-US" sz="2200" dirty="0"/>
+          </a:p>
+        </p:txBody>
+      </p:sp>
+      <p:sp>
+        <p:nvSpPr>
+          <p:cNvPr id="15" name="Shape 13"/>
+          <p:cNvSpPr/>
+          <p:nvPr/>
+        </p:nvSpPr>
+        <p:spPr>
+          <a:xfrm>
+            <a:off x="6126480" y="2286000"/>
+            <a:ext cx="2468880" cy="2148840"/>
+          </a:xfrm>
+          <a:prstGeom prst="roundRect">
+            <a:avLst>
+              <a:gd name="adj" fmla="val 3404"/>
+            </a:avLst>
+          </a:prstGeom>
+          <a:solidFill>
+            <a:srgbClr val="FBFAF6"/>
+          </a:solidFill>
+          <a:ln w="12700">
+            <a:solidFill>
+              <a:srgbClr val="E4DDCB"/>
+            </a:solidFill>
+            <a:prstDash val="solid"/>
+          </a:ln>
+          <a:effectLst>
+            <a:outerShdw sx="100000" sy="100000" kx="0" ky="0" algn="bl" rotWithShape="0" blurRad="114300" dist="38100" dir="5400000">
+              <a:srgbClr val="6B5A2A">
+                <a:alpha val="18000"/>
+              </a:srgbClr>
+            </a:outerShdw>
+          </a:effectLst>
+        </p:spPr>
+      </p:sp>
+      <p:sp>
+        <p:nvSpPr>
+          <p:cNvPr id="16" name="Text 14"/>
+          <p:cNvSpPr/>
+          <p:nvPr/>
+        </p:nvSpPr>
+        <p:spPr>
+          <a:xfrm>
+            <a:off x="6263640" y="2651760"/>
+            <a:ext cx="2194560" cy="731520"/>
+          </a:xfrm>
+          <a:prstGeom prst="rect">
+            <a:avLst/>
+          </a:prstGeom>
+          <a:noFill/>
+          <a:ln/>
+        </p:spPr>
+        <p:txBody>
+          <a:bodyPr wrap="square" rtlCol="0" anchor="ctr"/>
+          <a:lstStyle/>
+          <a:p>
+            <a:pPr algn="ctr" indent="0" marL="0">
+              <a:buNone/>
+            </a:pPr>
+            <a:r>
+              <a:rPr lang="en-US" sz="3600" b="1" dirty="0">
+                <a:solidFill>
+                  <a:srgbClr val="1B160B"/>
+                </a:solidFill>
+                <a:latin typeface="Cambria" pitchFamily="34" charset="0"/>
+                <a:ea typeface="Cambria" pitchFamily="34" charset="-122"/>
+                <a:cs typeface="Cambria" pitchFamily="34" charset="-120"/>
+              </a:rPr>
+              <a:t>~188</a:t>
+            </a:r>
+            <a:endParaRPr lang="en-US" sz="3600" dirty="0"/>
+          </a:p>
+        </p:txBody>
+      </p:sp>
+      <p:sp>
+        <p:nvSpPr>
+          <p:cNvPr id="17" name="Text 15"/>
+          <p:cNvSpPr/>
+          <p:nvPr/>
+        </p:nvSpPr>
+        <p:spPr>
+          <a:xfrm>
+            <a:off x="6263640" y="3520440"/>
+            <a:ext cx="2194560" cy="274320"/>
+          </a:xfrm>
+          <a:prstGeom prst="rect">
+            <a:avLst/>
+          </a:prstGeom>
+          <a:noFill/>
+          <a:ln/>
+        </p:spPr>
+        <p:txBody>
+          <a:bodyPr wrap="square" rtlCol="0" anchor="ctr"/>
+          <a:lstStyle/>
+          <a:p>
+            <a:pPr algn="ctr" indent="0" marL="0">
+              <a:buNone/>
+            </a:pPr>
+            <a:r>
+              <a:rPr lang="en-US" sz="1050" b="1" spc="60" kern="0" dirty="0">
                 <a:solidFill>
                   <a:srgbClr val="8A8272"/>
                 </a:solidFill>
@@ -4860,15 +4899,554 @@
                 <a:ea typeface="Calibri" pitchFamily="34" charset="-122"/>
                 <a:cs typeface="Calibri" pitchFamily="34" charset="-120"/>
               </a:rPr>
-              <a:t> — mail is a rounding error next to the commissions each listing earns, so every realistic capture rate stays comfortably profitable. Commission-compression sensitivity is in the appendix.</a:t>
-            </a:r>
-            <a:endParaRPr lang="en-US" sz="1150" dirty="0"/>
+              <a:t>LEADS CAPTURED</a:t>
+            </a:r>
+            <a:endParaRPr lang="en-US" sz="1050" dirty="0"/>
           </a:p>
         </p:txBody>
       </p:sp>
       <p:sp>
         <p:nvSpPr>
           <p:cNvPr id="18" name="Text 16"/>
+          <p:cNvSpPr/>
+          <p:nvPr/>
+        </p:nvSpPr>
+        <p:spPr>
+          <a:xfrm>
+            <a:off x="6217920" y="3822192"/>
+            <a:ext cx="2286000" cy="457200"/>
+          </a:xfrm>
+          <a:prstGeom prst="rect">
+            <a:avLst/>
+          </a:prstGeom>
+          <a:noFill/>
+          <a:ln/>
+        </p:spPr>
+        <p:txBody>
+          <a:bodyPr wrap="square" rtlCol="0" anchor="ctr"/>
+          <a:lstStyle/>
+          <a:p>
+            <a:pPr algn="ctr" indent="0" marL="0">
+              <a:lnSpc>
+                <a:spcPct val="100000"/>
+              </a:lnSpc>
+              <a:buNone/>
+            </a:pPr>
+            <a:r>
+              <a:rPr lang="en-US" sz="1100" dirty="0">
+                <a:solidFill>
+                  <a:srgbClr val="4A4436"/>
+                </a:solidFill>
+                <a:latin typeface="Calibri" pitchFamily="34" charset="0"/>
+                <a:ea typeface="Calibri" pitchFamily="34" charset="-122"/>
+                <a:cs typeface="Calibri" pitchFamily="34" charset="-120"/>
+              </a:rPr>
+              <a:t>40% of leads</a:t>
+            </a:r>
+            <a:endParaRPr lang="en-US" sz="1100" dirty="0"/>
+          </a:p>
+        </p:txBody>
+      </p:sp>
+      <p:sp>
+        <p:nvSpPr>
+          <p:cNvPr id="19" name="Text 17"/>
+          <p:cNvSpPr/>
+          <p:nvPr/>
+        </p:nvSpPr>
+        <p:spPr>
+          <a:xfrm>
+            <a:off x="8522208" y="2880360"/>
+            <a:ext cx="457200" cy="457200"/>
+          </a:xfrm>
+          <a:prstGeom prst="rect">
+            <a:avLst/>
+          </a:prstGeom>
+          <a:noFill/>
+          <a:ln/>
+        </p:spPr>
+        <p:txBody>
+          <a:bodyPr wrap="square" rtlCol="0" anchor="ctr"/>
+          <a:lstStyle/>
+          <a:p>
+            <a:pPr algn="ctr" indent="0" marL="0">
+              <a:buNone/>
+            </a:pPr>
+            <a:r>
+              <a:rPr lang="en-US" sz="2200" b="1" dirty="0">
+                <a:solidFill>
+                  <a:srgbClr val="B0842F"/>
+                </a:solidFill>
+                <a:latin typeface="Calibri" pitchFamily="34" charset="0"/>
+                <a:ea typeface="Calibri" pitchFamily="34" charset="-122"/>
+                <a:cs typeface="Calibri" pitchFamily="34" charset="-120"/>
+              </a:rPr>
+              <a:t>→</a:t>
+            </a:r>
+            <a:endParaRPr lang="en-US" sz="2200" dirty="0"/>
+          </a:p>
+        </p:txBody>
+      </p:sp>
+      <p:sp>
+        <p:nvSpPr>
+          <p:cNvPr id="20" name="Shape 18"/>
+          <p:cNvSpPr/>
+          <p:nvPr/>
+        </p:nvSpPr>
+        <p:spPr>
+          <a:xfrm>
+            <a:off x="8869680" y="2286000"/>
+            <a:ext cx="2468880" cy="2148840"/>
+          </a:xfrm>
+          <a:prstGeom prst="roundRect">
+            <a:avLst>
+              <a:gd name="adj" fmla="val 3404"/>
+            </a:avLst>
+          </a:prstGeom>
+          <a:solidFill>
+            <a:srgbClr val="FBFAF6"/>
+          </a:solidFill>
+          <a:ln w="12700">
+            <a:solidFill>
+              <a:srgbClr val="E4DDCB"/>
+            </a:solidFill>
+            <a:prstDash val="solid"/>
+          </a:ln>
+          <a:effectLst>
+            <a:outerShdw sx="100000" sy="100000" kx="0" ky="0" algn="bl" rotWithShape="0" blurRad="114300" dist="38100" dir="5400000">
+              <a:srgbClr val="6B5A2A">
+                <a:alpha val="18000"/>
+              </a:srgbClr>
+            </a:outerShdw>
+          </a:effectLst>
+        </p:spPr>
+      </p:sp>
+      <p:sp>
+        <p:nvSpPr>
+          <p:cNvPr id="21" name="Text 19"/>
+          <p:cNvSpPr/>
+          <p:nvPr/>
+        </p:nvSpPr>
+        <p:spPr>
+          <a:xfrm>
+            <a:off x="9006840" y="2651760"/>
+            <a:ext cx="2194560" cy="731520"/>
+          </a:xfrm>
+          <a:prstGeom prst="rect">
+            <a:avLst/>
+          </a:prstGeom>
+          <a:noFill/>
+          <a:ln/>
+        </p:spPr>
+        <p:txBody>
+          <a:bodyPr wrap="square" rtlCol="0" anchor="ctr"/>
+          <a:lstStyle/>
+          <a:p>
+            <a:pPr algn="ctr" indent="0" marL="0">
+              <a:buNone/>
+            </a:pPr>
+            <a:r>
+              <a:rPr lang="en-US" sz="3600" b="1" dirty="0">
+                <a:solidFill>
+                  <a:srgbClr val="1E7A44"/>
+                </a:solidFill>
+                <a:latin typeface="Cambria" pitchFamily="34" charset="0"/>
+                <a:ea typeface="Cambria" pitchFamily="34" charset="-122"/>
+                <a:cs typeface="Cambria" pitchFamily="34" charset="-120"/>
+              </a:rPr>
+              <a:t>29.8</a:t>
+            </a:r>
+            <a:endParaRPr lang="en-US" sz="3600" dirty="0"/>
+          </a:p>
+        </p:txBody>
+      </p:sp>
+      <p:sp>
+        <p:nvSpPr>
+          <p:cNvPr id="22" name="Text 20"/>
+          <p:cNvSpPr/>
+          <p:nvPr/>
+        </p:nvSpPr>
+        <p:spPr>
+          <a:xfrm>
+            <a:off x="9006840" y="3520440"/>
+            <a:ext cx="2194560" cy="274320"/>
+          </a:xfrm>
+          <a:prstGeom prst="rect">
+            <a:avLst/>
+          </a:prstGeom>
+          <a:noFill/>
+          <a:ln/>
+        </p:spPr>
+        <p:txBody>
+          <a:bodyPr wrap="square" rtlCol="0" anchor="ctr"/>
+          <a:lstStyle/>
+          <a:p>
+            <a:pPr algn="ctr" indent="0" marL="0">
+              <a:buNone/>
+            </a:pPr>
+            <a:r>
+              <a:rPr lang="en-US" sz="1050" b="1" spc="60" kern="0" dirty="0">
+                <a:solidFill>
+                  <a:srgbClr val="8A8272"/>
+                </a:solidFill>
+                <a:latin typeface="Calibri" pitchFamily="34" charset="0"/>
+                <a:ea typeface="Calibri" pitchFamily="34" charset="-122"/>
+                <a:cs typeface="Calibri" pitchFamily="34" charset="-120"/>
+              </a:rPr>
+              <a:t>LISTINGS CONVERTED</a:t>
+            </a:r>
+            <a:endParaRPr lang="en-US" sz="1050" dirty="0"/>
+          </a:p>
+        </p:txBody>
+      </p:sp>
+      <p:sp>
+        <p:nvSpPr>
+          <p:cNvPr id="23" name="Text 21"/>
+          <p:cNvSpPr/>
+          <p:nvPr/>
+        </p:nvSpPr>
+        <p:spPr>
+          <a:xfrm>
+            <a:off x="8961120" y="3822192"/>
+            <a:ext cx="2286000" cy="457200"/>
+          </a:xfrm>
+          <a:prstGeom prst="rect">
+            <a:avLst/>
+          </a:prstGeom>
+          <a:noFill/>
+          <a:ln/>
+        </p:spPr>
+        <p:txBody>
+          <a:bodyPr wrap="square" rtlCol="0" anchor="ctr"/>
+          <a:lstStyle/>
+          <a:p>
+            <a:pPr algn="ctr" indent="0" marL="0">
+              <a:lnSpc>
+                <a:spcPct val="100000"/>
+              </a:lnSpc>
+              <a:buNone/>
+            </a:pPr>
+            <a:r>
+              <a:rPr lang="en-US" sz="1100" dirty="0">
+                <a:solidFill>
+                  <a:srgbClr val="4A4436"/>
+                </a:solidFill>
+                <a:latin typeface="Calibri" pitchFamily="34" charset="0"/>
+                <a:ea typeface="Calibri" pitchFamily="34" charset="-122"/>
+                <a:cs typeface="Calibri" pitchFamily="34" charset="-120"/>
+              </a:rPr>
+              <a:t>16% of captured</a:t>
+            </a:r>
+            <a:endParaRPr lang="en-US" sz="1100" dirty="0"/>
+          </a:p>
+        </p:txBody>
+      </p:sp>
+      <p:sp>
+        <p:nvSpPr>
+          <p:cNvPr id="24" name="Shape 22"/>
+          <p:cNvSpPr/>
+          <p:nvPr/>
+        </p:nvSpPr>
+        <p:spPr>
+          <a:xfrm>
+            <a:off x="640080" y="4754880"/>
+            <a:ext cx="10881360" cy="1051560"/>
+          </a:xfrm>
+          <a:prstGeom prst="roundRect">
+            <a:avLst>
+              <a:gd name="adj" fmla="val 6957"/>
+            </a:avLst>
+          </a:prstGeom>
+          <a:solidFill>
+            <a:srgbClr val="0E1E33"/>
+          </a:solidFill>
+          <a:ln/>
+          <a:effectLst>
+            <a:outerShdw sx="100000" sy="100000" kx="0" ky="0" algn="bl" rotWithShape="0" blurRad="114300" dist="38100" dir="5400000">
+              <a:srgbClr val="6B5A2A">
+                <a:alpha val="18000"/>
+              </a:srgbClr>
+            </a:outerShdw>
+          </a:effectLst>
+        </p:spPr>
+      </p:sp>
+      <p:sp>
+        <p:nvSpPr>
+          <p:cNvPr id="25" name="Text 23"/>
+          <p:cNvSpPr/>
+          <p:nvPr/>
+        </p:nvSpPr>
+        <p:spPr>
+          <a:xfrm>
+            <a:off x="960120" y="4956048"/>
+            <a:ext cx="7132320" cy="256032"/>
+          </a:xfrm>
+          <a:prstGeom prst="rect">
+            <a:avLst/>
+          </a:prstGeom>
+          <a:noFill/>
+          <a:ln/>
+        </p:spPr>
+        <p:txBody>
+          <a:bodyPr wrap="square" rtlCol="0" anchor="ctr"/>
+          <a:lstStyle/>
+          <a:p>
+            <a:pPr indent="0" marL="0">
+              <a:buNone/>
+            </a:pPr>
+            <a:r>
+              <a:rPr lang="en-US" sz="1050" b="1" spc="160" kern="0" dirty="0">
+                <a:solidFill>
+                  <a:srgbClr val="B0842F"/>
+                </a:solidFill>
+                <a:latin typeface="Calibri" pitchFamily="34" charset="0"/>
+                <a:ea typeface="Calibri" pitchFamily="34" charset="-122"/>
+                <a:cs typeface="Calibri" pitchFamily="34" charset="-120"/>
+              </a:rPr>
+              <a:t>COVERS THE AD SPEND MANY TIMES OVER</a:t>
+            </a:r>
+            <a:endParaRPr lang="en-US" sz="1050" dirty="0"/>
+          </a:p>
+        </p:txBody>
+      </p:sp>
+      <p:sp>
+        <p:nvSpPr>
+          <p:cNvPr id="26" name="Text 24"/>
+          <p:cNvSpPr/>
+          <p:nvPr/>
+        </p:nvSpPr>
+        <p:spPr>
+          <a:xfrm>
+            <a:off x="960120" y="5212080"/>
+            <a:ext cx="7315200" cy="594360"/>
+          </a:xfrm>
+          <a:prstGeom prst="rect">
+            <a:avLst/>
+          </a:prstGeom>
+          <a:noFill/>
+          <a:ln/>
+        </p:spPr>
+        <p:txBody>
+          <a:bodyPr wrap="square" rtlCol="0" anchor="ctr"/>
+          <a:lstStyle/>
+          <a:p>
+            <a:pPr algn="l" indent="0" marL="0">
+              <a:lnSpc>
+                <a:spcPct val="103000"/>
+              </a:lnSpc>
+              <a:buNone/>
+            </a:pPr>
+            <a:r>
+              <a:rPr lang="en-US" sz="1400" b="1" dirty="0">
+                <a:solidFill>
+                  <a:srgbClr val="FBF8EF"/>
+                </a:solidFill>
+                <a:latin typeface="Calibri" pitchFamily="34" charset="0"/>
+                <a:ea typeface="Calibri" pitchFamily="34" charset="-122"/>
+                <a:cs typeface="Calibri" pitchFamily="34" charset="-120"/>
+              </a:rPr>
+              <a:t>Just ~2.4 listings</a:t>
+            </a:r>
+            <a:pPr algn="l" indent="0" marL="0">
+              <a:lnSpc>
+                <a:spcPct val="103000"/>
+              </a:lnSpc>
+              <a:buNone/>
+            </a:pPr>
+            <a:r>
+              <a:rPr lang="en-US" sz="1400" dirty="0">
+                <a:solidFill>
+                  <a:srgbClr val="C9D3E4"/>
+                </a:solidFill>
+                <a:latin typeface="Calibri" pitchFamily="34" charset="0"/>
+                <a:ea typeface="Calibri" pitchFamily="34" charset="-122"/>
+                <a:cs typeface="Calibri" pitchFamily="34" charset="-120"/>
+              </a:rPr>
+              <a:t> cover the full $36,660 — 8% of the funnel's output. Capture and conversion could </a:t>
+            </a:r>
+            <a:pPr algn="l" indent="0" marL="0">
+              <a:lnSpc>
+                <a:spcPct val="103000"/>
+              </a:lnSpc>
+              <a:buNone/>
+            </a:pPr>
+            <a:r>
+              <a:rPr lang="en-US" sz="1400" b="1" dirty="0">
+                <a:solidFill>
+                  <a:srgbClr val="FBF8EF"/>
+                </a:solidFill>
+                <a:latin typeface="Calibri" pitchFamily="34" charset="0"/>
+                <a:ea typeface="Calibri" pitchFamily="34" charset="-122"/>
+                <a:cs typeface="Calibri" pitchFamily="34" charset="-120"/>
+              </a:rPr>
+              <a:t>both halve</a:t>
+            </a:r>
+            <a:pPr algn="l" indent="0" marL="0">
+              <a:lnSpc>
+                <a:spcPct val="103000"/>
+              </a:lnSpc>
+              <a:buNone/>
+            </a:pPr>
+            <a:r>
+              <a:rPr lang="en-US" sz="1400" dirty="0">
+                <a:solidFill>
+                  <a:srgbClr val="C9D3E4"/>
+                </a:solidFill>
+                <a:latin typeface="Calibri" pitchFamily="34" charset="0"/>
+                <a:ea typeface="Calibri" pitchFamily="34" charset="-122"/>
+                <a:cs typeface="Calibri" pitchFamily="34" charset="-120"/>
+              </a:rPr>
+              <a:t> and the spend is still covered 3× over.</a:t>
+            </a:r>
+            <a:endParaRPr lang="en-US" sz="1400" dirty="0"/>
+          </a:p>
+        </p:txBody>
+      </p:sp>
+      <p:sp>
+        <p:nvSpPr>
+          <p:cNvPr id="27" name="Shape 25"/>
+          <p:cNvSpPr/>
+          <p:nvPr/>
+        </p:nvSpPr>
+        <p:spPr>
+          <a:xfrm>
+            <a:off x="8549640" y="5029200"/>
+            <a:ext cx="0" cy="594360"/>
+          </a:xfrm>
+          <a:prstGeom prst="line">
+            <a:avLst/>
+          </a:prstGeom>
+          <a:noFill/>
+          <a:ln w="12700">
+            <a:solidFill>
+              <a:srgbClr val="6E5A2E"/>
+            </a:solidFill>
+            <a:prstDash val="solid"/>
+          </a:ln>
+        </p:spPr>
+      </p:sp>
+      <p:sp>
+        <p:nvSpPr>
+          <p:cNvPr id="28" name="Text 26"/>
+          <p:cNvSpPr/>
+          <p:nvPr/>
+        </p:nvSpPr>
+        <p:spPr>
+          <a:xfrm>
+            <a:off x="8778240" y="4956048"/>
+            <a:ext cx="2743200" cy="566928"/>
+          </a:xfrm>
+          <a:prstGeom prst="rect">
+            <a:avLst/>
+          </a:prstGeom>
+          <a:noFill/>
+          <a:ln/>
+        </p:spPr>
+        <p:txBody>
+          <a:bodyPr wrap="square" rtlCol="0" anchor="ctr"/>
+          <a:lstStyle/>
+          <a:p>
+            <a:pPr algn="ctr" indent="0" marL="0">
+              <a:buNone/>
+            </a:pPr>
+            <a:r>
+              <a:rPr lang="en-US" sz="3800" b="1" dirty="0">
+                <a:solidFill>
+                  <a:srgbClr val="B0842F"/>
+                </a:solidFill>
+                <a:latin typeface="Cambria" pitchFamily="34" charset="0"/>
+                <a:ea typeface="Cambria" pitchFamily="34" charset="-122"/>
+                <a:cs typeface="Cambria" pitchFamily="34" charset="-120"/>
+              </a:rPr>
+              <a:t>≈12×</a:t>
+            </a:r>
+            <a:endParaRPr lang="en-US" sz="3800" dirty="0"/>
+          </a:p>
+        </p:txBody>
+      </p:sp>
+      <p:sp>
+        <p:nvSpPr>
+          <p:cNvPr id="29" name="Text 27"/>
+          <p:cNvSpPr/>
+          <p:nvPr/>
+        </p:nvSpPr>
+        <p:spPr>
+          <a:xfrm>
+            <a:off x="8641080" y="5504688"/>
+            <a:ext cx="3063240" cy="365760"/>
+          </a:xfrm>
+          <a:prstGeom prst="rect">
+            <a:avLst/>
+          </a:prstGeom>
+          <a:noFill/>
+          <a:ln/>
+        </p:spPr>
+        <p:txBody>
+          <a:bodyPr wrap="square" rtlCol="0" anchor="ctr"/>
+          <a:lstStyle/>
+          <a:p>
+            <a:pPr algn="ctr" indent="0" marL="0">
+              <a:lnSpc>
+                <a:spcPct val="100000"/>
+              </a:lnSpc>
+              <a:buNone/>
+            </a:pPr>
+            <a:r>
+              <a:rPr lang="en-US" sz="900" dirty="0">
+                <a:solidFill>
+                  <a:srgbClr val="9A9482"/>
+                </a:solidFill>
+                <a:latin typeface="Calibri" pitchFamily="34" charset="0"/>
+                <a:ea typeface="Calibri" pitchFamily="34" charset="-122"/>
+                <a:cs typeface="Calibri" pitchFamily="34" charset="-120"/>
+              </a:rPr>
+              <a:t>cushion at plan · 3× if the funnel halves</a:t>
+            </a:r>
+            <a:endParaRPr lang="en-US" sz="900" dirty="0"/>
+          </a:p>
+        </p:txBody>
+      </p:sp>
+      <p:sp>
+        <p:nvSpPr>
+          <p:cNvPr id="30" name="Text 28"/>
+          <p:cNvSpPr/>
+          <p:nvPr/>
+        </p:nvSpPr>
+        <p:spPr>
+          <a:xfrm>
+            <a:off x="640080" y="5989320"/>
+            <a:ext cx="10881360" cy="365760"/>
+          </a:xfrm>
+          <a:prstGeom prst="rect">
+            <a:avLst/>
+          </a:prstGeom>
+          <a:noFill/>
+          <a:ln/>
+        </p:spPr>
+        <p:txBody>
+          <a:bodyPr wrap="square" rtlCol="0" anchor="ctr"/>
+          <a:lstStyle/>
+          <a:p>
+            <a:pPr algn="l" indent="0" marL="0">
+              <a:buNone/>
+            </a:pPr>
+            <a:r>
+              <a:rPr lang="en-US" sz="950" i="1" dirty="0">
+                <a:solidFill>
+                  <a:srgbClr val="8A8272"/>
+                </a:solidFill>
+                <a:latin typeface="Calibri" pitchFamily="34" charset="0"/>
+                <a:ea typeface="Calibri" pitchFamily="34" charset="-122"/>
+                <a:cs typeface="Calibri" pitchFamily="34" charset="-120"/>
+              </a:rPr>
+              <a:t>Engagement (~10% of homes), capture (~40%) and conversion (~16%) are modeled assumptions; ad spend and listings-won come from the model.</a:t>
+            </a:r>
+            <a:endParaRPr lang="en-US" sz="950" dirty="0"/>
+          </a:p>
+        </p:txBody>
+      </p:sp>
+      <p:sp>
+        <p:nvSpPr>
+          <p:cNvPr id="31" name="Text 29"/>
           <p:cNvSpPr/>
           <p:nvPr/>
         </p:nvSpPr>
@@ -4921,7 +5499,7 @@
       </p:sp>
       <p:sp>
         <p:nvSpPr>
-          <p:cNvPr id="19" name="Text 17"/>
+          <p:cNvPr id="32" name="Text 30"/>
           <p:cNvSpPr/>
           <p:nvPr/>
         </p:nvSpPr>

</xml_diff>

<commit_message>
Refocus Opportunity slide purely on market size
Replaces the lead-gen funnel (now on the Downside slide) with market-size
metrics: 6 neighborhoods, 4,700 homes, ~199 listings in play/yr (net of the
top agent), ~$3.0M annual commission pool, plus a footprint band with the
six neighborhood names, $550K-$1.0M value range, ~5% turnover, and ~$130M
in homes trading hands each year.

Co-Authored-By: Claude Opus 4.8 <noreply@anthropic.com>
Claude-Session: https://claude.ai/code/session_01Cyq3zkcaFRihnz3XVtX9JE
</commit_message>
<xml_diff>
--- a/presentations/Geo-Farming-Campaign.pptx
+++ b/presentations/Geo-Farming-Campaign.pptx
@@ -2084,7 +2084,7 @@
                 <a:ea typeface="Cambria" pitchFamily="34" charset="-122"/>
                 <a:cs typeface="Cambria" pitchFamily="34" charset="-120"/>
               </a:rPr>
-              <a:t>Ad spend that converts to listings — and pays for itself.</a:t>
+              <a:t>A ~$3M commission market, six neighborhoods deep.</a:t>
             </a:r>
             <a:endParaRPr lang="en-US" sz="3100" dirty="0"/>
           </a:p>
@@ -2126,7 +2126,7 @@
                 <a:ea typeface="Calibri" pitchFamily="34" charset="-122"/>
                 <a:cs typeface="Calibri" pitchFamily="34" charset="-120"/>
               </a:rPr>
-              <a:t>Farming turns a fixed, measurable ad budget into an owned lead pipeline across six neighborhoods. The conversion needed to cover the entire spend is a rounding error against the homes you reach.</a:t>
+              <a:t>The farm footprint is a large, stable, high-value market — thousands of owned homes turning over every year, with millions in listing commissions in play before the campaign captures a single one.</a:t>
             </a:r>
             <a:endParaRPr lang="en-US" sz="1450" dirty="0"/>
           </a:p>
@@ -2174,8 +2174,8 @@
         </p:nvSpPr>
         <p:spPr>
           <a:xfrm>
-            <a:off x="777240" y="2651760"/>
-            <a:ext cx="2194560" cy="731520"/>
+            <a:off x="731520" y="2651760"/>
+            <a:ext cx="2286000" cy="731520"/>
           </a:xfrm>
           <a:prstGeom prst="rect">
             <a:avLst/>
@@ -2199,7 +2199,7 @@
                 <a:ea typeface="Cambria" pitchFamily="34" charset="-122"/>
                 <a:cs typeface="Cambria" pitchFamily="34" charset="-120"/>
               </a:rPr>
-              <a:t>4,700</a:t>
+              <a:t>6</a:t>
             </a:r>
             <a:endParaRPr lang="en-US" sz="3600" dirty="0"/>
           </a:p>
@@ -2213,8 +2213,8 @@
         </p:nvSpPr>
         <p:spPr>
           <a:xfrm>
-            <a:off x="777240" y="3520440"/>
-            <a:ext cx="2194560" cy="274320"/>
+            <a:off x="731520" y="3520440"/>
+            <a:ext cx="2286000" cy="274320"/>
           </a:xfrm>
           <a:prstGeom prst="rect">
             <a:avLst/>
@@ -2230,7 +2230,7 @@
               <a:buNone/>
             </a:pPr>
             <a:r>
-              <a:rPr lang="en-US" sz="1050" b="1" spc="60" kern="0" dirty="0">
+              <a:rPr lang="en-US" sz="1050" b="1" spc="50" kern="0" dirty="0">
                 <a:solidFill>
                   <a:srgbClr val="8A8272"/>
                 </a:solidFill>
@@ -2238,7 +2238,7 @@
                 <a:ea typeface="Calibri" pitchFamily="34" charset="-122"/>
                 <a:cs typeface="Calibri" pitchFamily="34" charset="-120"/>
               </a:rPr>
-              <a:t>HOMES REACHED</a:t>
+              <a:t>NEIGHBORHOODS</a:t>
             </a:r>
             <a:endParaRPr lang="en-US" sz="1050" dirty="0"/>
           </a:p>
@@ -2280,7 +2280,7 @@
                 <a:ea typeface="Calibri" pitchFamily="34" charset="-122"/>
                 <a:cs typeface="Calibri" pitchFamily="34" charset="-120"/>
               </a:rPr>
-              <a:t>six farm neighborhoods</a:t>
+              <a:t>one contiguous footprint</a:t>
             </a:r>
             <a:endParaRPr lang="en-US" sz="1100" dirty="0"/>
           </a:p>
@@ -2288,46 +2288,7 @@
       </p:sp>
       <p:sp>
         <p:nvSpPr>
-          <p:cNvPr id="9" name="Text 7"/>
-          <p:cNvSpPr/>
-          <p:nvPr/>
-        </p:nvSpPr>
-        <p:spPr>
-          <a:xfrm>
-            <a:off x="3035808" y="2880360"/>
-            <a:ext cx="457200" cy="457200"/>
-          </a:xfrm>
-          <a:prstGeom prst="rect">
-            <a:avLst/>
-          </a:prstGeom>
-          <a:noFill/>
-          <a:ln/>
-        </p:spPr>
-        <p:txBody>
-          <a:bodyPr wrap="square" rtlCol="0" anchor="ctr"/>
-          <a:lstStyle/>
-          <a:p>
-            <a:pPr algn="ctr" indent="0" marL="0">
-              <a:buNone/>
-            </a:pPr>
-            <a:r>
-              <a:rPr lang="en-US" sz="2200" b="1" dirty="0">
-                <a:solidFill>
-                  <a:srgbClr val="B0842F"/>
-                </a:solidFill>
-                <a:latin typeface="Calibri" pitchFamily="34" charset="0"/>
-                <a:ea typeface="Calibri" pitchFamily="34" charset="-122"/>
-                <a:cs typeface="Calibri" pitchFamily="34" charset="-120"/>
-              </a:rPr>
-              <a:t>→</a:t>
-            </a:r>
-            <a:endParaRPr lang="en-US" sz="2200" dirty="0"/>
-          </a:p>
-        </p:txBody>
-      </p:sp>
-      <p:sp>
-        <p:nvSpPr>
-          <p:cNvPr id="10" name="Shape 8"/>
+          <p:cNvPr id="9" name="Shape 7"/>
           <p:cNvSpPr/>
           <p:nvPr/>
         </p:nvSpPr>
@@ -2361,14 +2322,14 @@
       </p:sp>
       <p:sp>
         <p:nvSpPr>
-          <p:cNvPr id="11" name="Text 9"/>
-          <p:cNvSpPr/>
-          <p:nvPr/>
-        </p:nvSpPr>
-        <p:spPr>
-          <a:xfrm>
-            <a:off x="3520440" y="2651760"/>
-            <a:ext cx="2194560" cy="731520"/>
+          <p:cNvPr id="10" name="Text 8"/>
+          <p:cNvSpPr/>
+          <p:nvPr/>
+        </p:nvSpPr>
+        <p:spPr>
+          <a:xfrm>
+            <a:off x="3474720" y="2651760"/>
+            <a:ext cx="2286000" cy="731520"/>
           </a:xfrm>
           <a:prstGeom prst="rect">
             <a:avLst/>
@@ -2386,13 +2347,13 @@
             <a:r>
               <a:rPr lang="en-US" sz="3600" b="1" dirty="0">
                 <a:solidFill>
-                  <a:srgbClr val="8A6A1E"/>
+                  <a:srgbClr val="1B160B"/>
                 </a:solidFill>
                 <a:latin typeface="Cambria" pitchFamily="34" charset="0"/>
                 <a:ea typeface="Cambria" pitchFamily="34" charset="-122"/>
                 <a:cs typeface="Cambria" pitchFamily="34" charset="-120"/>
               </a:rPr>
-              <a:t>$36,660</a:t>
+              <a:t>4,700</a:t>
             </a:r>
             <a:endParaRPr lang="en-US" sz="3600" dirty="0"/>
           </a:p>
@@ -2400,46 +2361,46 @@
       </p:sp>
       <p:sp>
         <p:nvSpPr>
+          <p:cNvPr id="11" name="Text 9"/>
+          <p:cNvSpPr/>
+          <p:nvPr/>
+        </p:nvSpPr>
+        <p:spPr>
+          <a:xfrm>
+            <a:off x="3474720" y="3520440"/>
+            <a:ext cx="2286000" cy="274320"/>
+          </a:xfrm>
+          <a:prstGeom prst="rect">
+            <a:avLst/>
+          </a:prstGeom>
+          <a:noFill/>
+          <a:ln/>
+        </p:spPr>
+        <p:txBody>
+          <a:bodyPr wrap="square" rtlCol="0" anchor="ctr"/>
+          <a:lstStyle/>
+          <a:p>
+            <a:pPr algn="ctr" indent="0" marL="0">
+              <a:buNone/>
+            </a:pPr>
+            <a:r>
+              <a:rPr lang="en-US" sz="1050" b="1" spc="50" kern="0" dirty="0">
+                <a:solidFill>
+                  <a:srgbClr val="8A8272"/>
+                </a:solidFill>
+                <a:latin typeface="Calibri" pitchFamily="34" charset="0"/>
+                <a:ea typeface="Calibri" pitchFamily="34" charset="-122"/>
+                <a:cs typeface="Calibri" pitchFamily="34" charset="-120"/>
+              </a:rPr>
+              <a:t>HOMES</a:t>
+            </a:r>
+            <a:endParaRPr lang="en-US" sz="1050" dirty="0"/>
+          </a:p>
+        </p:txBody>
+      </p:sp>
+      <p:sp>
+        <p:nvSpPr>
           <p:cNvPr id="12" name="Text 10"/>
-          <p:cNvSpPr/>
-          <p:nvPr/>
-        </p:nvSpPr>
-        <p:spPr>
-          <a:xfrm>
-            <a:off x="3520440" y="3520440"/>
-            <a:ext cx="2194560" cy="274320"/>
-          </a:xfrm>
-          <a:prstGeom prst="rect">
-            <a:avLst/>
-          </a:prstGeom>
-          <a:noFill/>
-          <a:ln/>
-        </p:spPr>
-        <p:txBody>
-          <a:bodyPr wrap="square" rtlCol="0" anchor="ctr"/>
-          <a:lstStyle/>
-          <a:p>
-            <a:pPr algn="ctr" indent="0" marL="0">
-              <a:buNone/>
-            </a:pPr>
-            <a:r>
-              <a:rPr lang="en-US" sz="1050" b="1" spc="60" kern="0" dirty="0">
-                <a:solidFill>
-                  <a:srgbClr val="8A8272"/>
-                </a:solidFill>
-                <a:latin typeface="Calibri" pitchFamily="34" charset="0"/>
-                <a:ea typeface="Calibri" pitchFamily="34" charset="-122"/>
-                <a:cs typeface="Calibri" pitchFamily="34" charset="-120"/>
-              </a:rPr>
-              <a:t>ANNUAL AD SPEND</a:t>
-            </a:r>
-            <a:endParaRPr lang="en-US" sz="1050" dirty="0"/>
-          </a:p>
-        </p:txBody>
-      </p:sp>
-      <p:sp>
-        <p:nvSpPr>
-          <p:cNvPr id="13" name="Text 11"/>
           <p:cNvSpPr/>
           <p:nvPr/>
         </p:nvSpPr>
@@ -2473,7 +2434,7 @@
                 <a:ea typeface="Calibri" pitchFamily="34" charset="-122"/>
                 <a:cs typeface="Calibri" pitchFamily="34" charset="-120"/>
               </a:rPr>
-              <a:t>$3,055/mo · ~$7.80 / home</a:t>
+              <a:t>in the farm footprint</a:t>
             </a:r>
             <a:endParaRPr lang="en-US" sz="1100" dirty="0"/>
           </a:p>
@@ -2481,46 +2442,7 @@
       </p:sp>
       <p:sp>
         <p:nvSpPr>
-          <p:cNvPr id="14" name="Text 12"/>
-          <p:cNvSpPr/>
-          <p:nvPr/>
-        </p:nvSpPr>
-        <p:spPr>
-          <a:xfrm>
-            <a:off x="5779008" y="2880360"/>
-            <a:ext cx="457200" cy="457200"/>
-          </a:xfrm>
-          <a:prstGeom prst="rect">
-            <a:avLst/>
-          </a:prstGeom>
-          <a:noFill/>
-          <a:ln/>
-        </p:spPr>
-        <p:txBody>
-          <a:bodyPr wrap="square" rtlCol="0" anchor="ctr"/>
-          <a:lstStyle/>
-          <a:p>
-            <a:pPr algn="ctr" indent="0" marL="0">
-              <a:buNone/>
-            </a:pPr>
-            <a:r>
-              <a:rPr lang="en-US" sz="2200" b="1" dirty="0">
-                <a:solidFill>
-                  <a:srgbClr val="B0842F"/>
-                </a:solidFill>
-                <a:latin typeface="Calibri" pitchFamily="34" charset="0"/>
-                <a:ea typeface="Calibri" pitchFamily="34" charset="-122"/>
-                <a:cs typeface="Calibri" pitchFamily="34" charset="-120"/>
-              </a:rPr>
-              <a:t>→</a:t>
-            </a:r>
-            <a:endParaRPr lang="en-US" sz="2200" dirty="0"/>
-          </a:p>
-        </p:txBody>
-      </p:sp>
-      <p:sp>
-        <p:nvSpPr>
-          <p:cNvPr id="15" name="Shape 13"/>
+          <p:cNvPr id="13" name="Shape 11"/>
           <p:cNvSpPr/>
           <p:nvPr/>
         </p:nvSpPr>
@@ -2554,14 +2476,14 @@
       </p:sp>
       <p:sp>
         <p:nvSpPr>
-          <p:cNvPr id="16" name="Text 14"/>
-          <p:cNvSpPr/>
-          <p:nvPr/>
-        </p:nvSpPr>
-        <p:spPr>
-          <a:xfrm>
-            <a:off x="6263640" y="2651760"/>
-            <a:ext cx="2194560" cy="731520"/>
+          <p:cNvPr id="14" name="Text 12"/>
+          <p:cNvSpPr/>
+          <p:nvPr/>
+        </p:nvSpPr>
+        <p:spPr>
+          <a:xfrm>
+            <a:off x="6217920" y="2651760"/>
+            <a:ext cx="2286000" cy="731520"/>
           </a:xfrm>
           <a:prstGeom prst="rect">
             <a:avLst/>
@@ -2585,7 +2507,7 @@
                 <a:ea typeface="Cambria" pitchFamily="34" charset="-122"/>
                 <a:cs typeface="Cambria" pitchFamily="34" charset="-120"/>
               </a:rPr>
-              <a:t>~470</a:t>
+              <a:t>~199</a:t>
             </a:r>
             <a:endParaRPr lang="en-US" sz="3600" dirty="0"/>
           </a:p>
@@ -2593,14 +2515,14 @@
       </p:sp>
       <p:sp>
         <p:nvSpPr>
-          <p:cNvPr id="17" name="Text 15"/>
-          <p:cNvSpPr/>
-          <p:nvPr/>
-        </p:nvSpPr>
-        <p:spPr>
-          <a:xfrm>
-            <a:off x="6263640" y="3520440"/>
-            <a:ext cx="2194560" cy="274320"/>
+          <p:cNvPr id="15" name="Text 13"/>
+          <p:cNvSpPr/>
+          <p:nvPr/>
+        </p:nvSpPr>
+        <p:spPr>
+          <a:xfrm>
+            <a:off x="6217920" y="3520440"/>
+            <a:ext cx="2286000" cy="274320"/>
           </a:xfrm>
           <a:prstGeom prst="rect">
             <a:avLst/>
@@ -2616,7 +2538,7 @@
               <a:buNone/>
             </a:pPr>
             <a:r>
-              <a:rPr lang="en-US" sz="1050" b="1" spc="60" kern="0" dirty="0">
+              <a:rPr lang="en-US" sz="1050" b="1" spc="50" kern="0" dirty="0">
                 <a:solidFill>
                   <a:srgbClr val="8A8272"/>
                 </a:solidFill>
@@ -2624,7 +2546,7 @@
                 <a:ea typeface="Calibri" pitchFamily="34" charset="-122"/>
                 <a:cs typeface="Calibri" pitchFamily="34" charset="-120"/>
               </a:rPr>
-              <a:t>SELLER LEADS / YR</a:t>
+              <a:t>LISTINGS IN PLAY / YR</a:t>
             </a:r>
             <a:endParaRPr lang="en-US" sz="1050" dirty="0"/>
           </a:p>
@@ -2632,7 +2554,7 @@
       </p:sp>
       <p:sp>
         <p:nvSpPr>
-          <p:cNvPr id="18" name="Text 16"/>
+          <p:cNvPr id="16" name="Text 14"/>
           <p:cNvSpPr/>
           <p:nvPr/>
         </p:nvSpPr>
@@ -2666,7 +2588,7 @@
                 <a:ea typeface="Calibri" pitchFamily="34" charset="-122"/>
                 <a:cs typeface="Calibri" pitchFamily="34" charset="-120"/>
               </a:rPr>
-              <a:t>modeled ~10% engagement</a:t>
+              <a:t>sell annually, net of the top agent</a:t>
             </a:r>
             <a:endParaRPr lang="en-US" sz="1100" dirty="0"/>
           </a:p>
@@ -2674,46 +2596,7 @@
       </p:sp>
       <p:sp>
         <p:nvSpPr>
-          <p:cNvPr id="19" name="Text 17"/>
-          <p:cNvSpPr/>
-          <p:nvPr/>
-        </p:nvSpPr>
-        <p:spPr>
-          <a:xfrm>
-            <a:off x="8522208" y="2880360"/>
-            <a:ext cx="457200" cy="457200"/>
-          </a:xfrm>
-          <a:prstGeom prst="rect">
-            <a:avLst/>
-          </a:prstGeom>
-          <a:noFill/>
-          <a:ln/>
-        </p:spPr>
-        <p:txBody>
-          <a:bodyPr wrap="square" rtlCol="0" anchor="ctr"/>
-          <a:lstStyle/>
-          <a:p>
-            <a:pPr algn="ctr" indent="0" marL="0">
-              <a:buNone/>
-            </a:pPr>
-            <a:r>
-              <a:rPr lang="en-US" sz="2200" b="1" dirty="0">
-                <a:solidFill>
-                  <a:srgbClr val="B0842F"/>
-                </a:solidFill>
-                <a:latin typeface="Calibri" pitchFamily="34" charset="0"/>
-                <a:ea typeface="Calibri" pitchFamily="34" charset="-122"/>
-                <a:cs typeface="Calibri" pitchFamily="34" charset="-120"/>
-              </a:rPr>
-              <a:t>→</a:t>
-            </a:r>
-            <a:endParaRPr lang="en-US" sz="2200" dirty="0"/>
-          </a:p>
-        </p:txBody>
-      </p:sp>
-      <p:sp>
-        <p:nvSpPr>
-          <p:cNvPr id="20" name="Shape 18"/>
+          <p:cNvPr id="17" name="Shape 15"/>
           <p:cNvSpPr/>
           <p:nvPr/>
         </p:nvSpPr>
@@ -2747,14 +2630,14 @@
       </p:sp>
       <p:sp>
         <p:nvSpPr>
-          <p:cNvPr id="21" name="Text 19"/>
-          <p:cNvSpPr/>
-          <p:nvPr/>
-        </p:nvSpPr>
-        <p:spPr>
-          <a:xfrm>
-            <a:off x="9006840" y="2651760"/>
-            <a:ext cx="2194560" cy="731520"/>
+          <p:cNvPr id="18" name="Text 16"/>
+          <p:cNvSpPr/>
+          <p:nvPr/>
+        </p:nvSpPr>
+        <p:spPr>
+          <a:xfrm>
+            <a:off x="8961120" y="2651760"/>
+            <a:ext cx="2286000" cy="731520"/>
           </a:xfrm>
           <a:prstGeom prst="rect">
             <a:avLst/>
@@ -2778,7 +2661,7 @@
                 <a:ea typeface="Cambria" pitchFamily="34" charset="-122"/>
                 <a:cs typeface="Cambria" pitchFamily="34" charset="-120"/>
               </a:rPr>
-              <a:t>29.8</a:t>
+              <a:t>~$3.0M</a:t>
             </a:r>
             <a:endParaRPr lang="en-US" sz="3600" dirty="0"/>
           </a:p>
@@ -2786,14 +2669,14 @@
       </p:sp>
       <p:sp>
         <p:nvSpPr>
-          <p:cNvPr id="22" name="Text 20"/>
-          <p:cNvSpPr/>
-          <p:nvPr/>
-        </p:nvSpPr>
-        <p:spPr>
-          <a:xfrm>
-            <a:off x="9006840" y="3520440"/>
-            <a:ext cx="2194560" cy="274320"/>
+          <p:cNvPr id="19" name="Text 17"/>
+          <p:cNvSpPr/>
+          <p:nvPr/>
+        </p:nvSpPr>
+        <p:spPr>
+          <a:xfrm>
+            <a:off x="8961120" y="3520440"/>
+            <a:ext cx="2286000" cy="274320"/>
           </a:xfrm>
           <a:prstGeom prst="rect">
             <a:avLst/>
@@ -2809,7 +2692,7 @@
               <a:buNone/>
             </a:pPr>
             <a:r>
-              <a:rPr lang="en-US" sz="1050" b="1" spc="60" kern="0" dirty="0">
+              <a:rPr lang="en-US" sz="1050" b="1" spc="50" kern="0" dirty="0">
                 <a:solidFill>
                   <a:srgbClr val="8A8272"/>
                 </a:solidFill>
@@ -2817,7 +2700,7 @@
                 <a:ea typeface="Calibri" pitchFamily="34" charset="-122"/>
                 <a:cs typeface="Calibri" pitchFamily="34" charset="-120"/>
               </a:rPr>
-              <a:t>LISTINGS WON / YR</a:t>
+              <a:t>COMMISSION POOL / YR</a:t>
             </a:r>
             <a:endParaRPr lang="en-US" sz="1050" dirty="0"/>
           </a:p>
@@ -2825,7 +2708,7 @@
       </p:sp>
       <p:sp>
         <p:nvSpPr>
-          <p:cNvPr id="23" name="Text 21"/>
+          <p:cNvPr id="20" name="Text 18"/>
           <p:cNvSpPr/>
           <p:nvPr/>
         </p:nvSpPr>
@@ -2859,7 +2742,7 @@
                 <a:ea typeface="Calibri" pitchFamily="34" charset="-122"/>
                 <a:cs typeface="Calibri" pitchFamily="34" charset="-120"/>
               </a:rPr>
-              <a:t>≈ 6% of leads convert</a:t>
+              <a:t>in play across the six</a:t>
             </a:r>
             <a:endParaRPr lang="en-US" sz="1100" dirty="0"/>
           </a:p>
@@ -2867,18 +2750,18 @@
       </p:sp>
       <p:sp>
         <p:nvSpPr>
-          <p:cNvPr id="24" name="Shape 22"/>
+          <p:cNvPr id="21" name="Shape 19"/>
           <p:cNvSpPr/>
           <p:nvPr/>
         </p:nvSpPr>
         <p:spPr>
           <a:xfrm>
             <a:off x="640080" y="4754880"/>
-            <a:ext cx="10881360" cy="1143000"/>
+            <a:ext cx="10881360" cy="1051560"/>
           </a:xfrm>
           <a:prstGeom prst="roundRect">
             <a:avLst>
-              <a:gd name="adj" fmla="val 6400"/>
+              <a:gd name="adj" fmla="val 6957"/>
             </a:avLst>
           </a:prstGeom>
           <a:solidFill>
@@ -2896,14 +2779,14 @@
       </p:sp>
       <p:sp>
         <p:nvSpPr>
-          <p:cNvPr id="25" name="Text 23"/>
+          <p:cNvPr id="22" name="Text 20"/>
           <p:cNvSpPr/>
           <p:nvPr/>
         </p:nvSpPr>
         <p:spPr>
           <a:xfrm>
             <a:off x="960120" y="4956048"/>
-            <a:ext cx="6858000" cy="256032"/>
+            <a:ext cx="4572000" cy="256032"/>
           </a:xfrm>
           <a:prstGeom prst="rect">
             <a:avLst/>
@@ -2927,7 +2810,7 @@
                 <a:ea typeface="Calibri" pitchFamily="34" charset="-122"/>
                 <a:cs typeface="Calibri" pitchFamily="34" charset="-120"/>
               </a:rPr>
-              <a:t>COVERS THE ENTIRE AD SPEND</a:t>
+              <a:t>THE FOOTPRINT</a:t>
             </a:r>
             <a:endParaRPr lang="en-US" sz="1050" dirty="0"/>
           </a:p>
@@ -2935,14 +2818,14 @@
       </p:sp>
       <p:sp>
         <p:nvSpPr>
-          <p:cNvPr id="26" name="Text 24"/>
-          <p:cNvSpPr/>
-          <p:nvPr/>
-        </p:nvSpPr>
-        <p:spPr>
-          <a:xfrm>
-            <a:off x="960120" y="5212080"/>
-            <a:ext cx="7315200" cy="594360"/>
+          <p:cNvPr id="23" name="Text 21"/>
+          <p:cNvSpPr/>
+          <p:nvPr/>
+        </p:nvSpPr>
+        <p:spPr>
+          <a:xfrm>
+            <a:off x="960120" y="5230368"/>
+            <a:ext cx="7589520" cy="310896"/>
           </a:xfrm>
           <a:prstGeom prst="rect">
             <a:avLst/>
@@ -2955,13 +2838,10 @@
           <a:lstStyle/>
           <a:p>
             <a:pPr algn="l" indent="0" marL="0">
-              <a:lnSpc>
-                <a:spcPct val="103000"/>
-              </a:lnSpc>
-              <a:buNone/>
-            </a:pPr>
-            <a:r>
-              <a:rPr lang="en-US" sz="1400" b="1" dirty="0">
+              <a:buNone/>
+            </a:pPr>
+            <a:r>
+              <a:rPr lang="en-US" sz="1350" b="1" dirty="0">
                 <a:solidFill>
                   <a:srgbClr val="FBF8EF"/>
                 </a:solidFill>
@@ -2969,16 +2849,38 @@
                 <a:ea typeface="Calibri" pitchFamily="34" charset="-122"/>
                 <a:cs typeface="Calibri" pitchFamily="34" charset="-120"/>
               </a:rPr>
-              <a:t>Just ~2.4 listings a year</a:t>
-            </a:r>
+              <a:t>Hamilton Proper · Gray Eagle · Britton Falls · Sunblest · Geist · Windermere</a:t>
+            </a:r>
+            <a:endParaRPr lang="en-US" sz="1350" dirty="0"/>
+          </a:p>
+        </p:txBody>
+      </p:sp>
+      <p:sp>
+        <p:nvSpPr>
+          <p:cNvPr id="24" name="Text 22"/>
+          <p:cNvSpPr/>
+          <p:nvPr/>
+        </p:nvSpPr>
+        <p:spPr>
+          <a:xfrm>
+            <a:off x="960120" y="5522976"/>
+            <a:ext cx="7589520" cy="274320"/>
+          </a:xfrm>
+          <a:prstGeom prst="rect">
+            <a:avLst/>
+          </a:prstGeom>
+          <a:noFill/>
+          <a:ln/>
+        </p:spPr>
+        <p:txBody>
+          <a:bodyPr wrap="square" rtlCol="0" anchor="ctr"/>
+          <a:lstStyle/>
+          <a:p>
             <a:pPr algn="l" indent="0" marL="0">
-              <a:lnSpc>
-                <a:spcPct val="103000"/>
-              </a:lnSpc>
-              <a:buNone/>
-            </a:pPr>
-            <a:r>
-              <a:rPr lang="en-US" sz="1400" dirty="0">
+              <a:buNone/>
+            </a:pPr>
+            <a:r>
+              <a:rPr lang="en-US" sz="1200" dirty="0">
                 <a:solidFill>
                   <a:srgbClr val="C9D3E4"/>
                 </a:solidFill>
@@ -2986,16 +2888,13 @@
                 <a:ea typeface="Calibri" pitchFamily="34" charset="-122"/>
                 <a:cs typeface="Calibri" pitchFamily="34" charset="-120"/>
               </a:rPr>
-              <a:t> cover the full $36,660 ad spend — a </a:t>
+              <a:t>Median home values </a:t>
             </a:r>
             <a:pPr algn="l" indent="0" marL="0">
-              <a:lnSpc>
-                <a:spcPct val="103000"/>
-              </a:lnSpc>
-              <a:buNone/>
-            </a:pPr>
-            <a:r>
-              <a:rPr lang="en-US" sz="1400" b="1" dirty="0">
+              <a:buNone/>
+            </a:pPr>
+            <a:r>
+              <a:rPr lang="en-US" sz="1200" b="1" dirty="0">
                 <a:solidFill>
                   <a:srgbClr val="FBF8EF"/>
                 </a:solidFill>
@@ -3003,16 +2902,13 @@
                 <a:ea typeface="Calibri" pitchFamily="34" charset="-122"/>
                 <a:cs typeface="Calibri" pitchFamily="34" charset="-120"/>
               </a:rPr>
-              <a:t>0.5% lead-to-listing conversion</a:t>
+              <a:t>$550K–$1.0M</a:t>
             </a:r>
             <a:pPr algn="l" indent="0" marL="0">
-              <a:lnSpc>
-                <a:spcPct val="103000"/>
-              </a:lnSpc>
-              <a:buNone/>
-            </a:pPr>
-            <a:r>
-              <a:rPr lang="en-US" sz="1400" dirty="0">
+              <a:buNone/>
+            </a:pPr>
+            <a:r>
+              <a:rPr lang="en-US" sz="1200" dirty="0">
                 <a:solidFill>
                   <a:srgbClr val="C9D3E4"/>
                 </a:solidFill>
@@ -3020,21 +2916,21 @@
                 <a:ea typeface="Calibri" pitchFamily="34" charset="-122"/>
                 <a:cs typeface="Calibri" pitchFamily="34" charset="-120"/>
               </a:rPr>
-              <a:t>, well under 1% of the homes you reach.</a:t>
-            </a:r>
-            <a:endParaRPr lang="en-US" sz="1400" dirty="0"/>
-          </a:p>
-        </p:txBody>
-      </p:sp>
-      <p:sp>
-        <p:nvSpPr>
-          <p:cNvPr id="27" name="Shape 25"/>
-          <p:cNvSpPr/>
-          <p:nvPr/>
-        </p:nvSpPr>
-        <p:spPr>
-          <a:xfrm>
-            <a:off x="8549640" y="5029200"/>
+              <a:t>   ·   about 5% of homes turn over every year.</a:t>
+            </a:r>
+            <a:endParaRPr lang="en-US" sz="1200" dirty="0"/>
+          </a:p>
+        </p:txBody>
+      </p:sp>
+      <p:sp>
+        <p:nvSpPr>
+          <p:cNvPr id="25" name="Shape 23"/>
+          <p:cNvSpPr/>
+          <p:nvPr/>
+        </p:nvSpPr>
+        <p:spPr>
+          <a:xfrm>
+            <a:off x="8778240" y="5029200"/>
             <a:ext cx="0" cy="594360"/>
           </a:xfrm>
           <a:prstGeom prst="line">
@@ -3051,14 +2947,14 @@
       </p:sp>
       <p:sp>
         <p:nvSpPr>
-          <p:cNvPr id="28" name="Text 26"/>
-          <p:cNvSpPr/>
-          <p:nvPr/>
-        </p:nvSpPr>
-        <p:spPr>
-          <a:xfrm>
-            <a:off x="8778240" y="4956048"/>
-            <a:ext cx="2743200" cy="566928"/>
+          <p:cNvPr id="26" name="Text 24"/>
+          <p:cNvSpPr/>
+          <p:nvPr/>
+        </p:nvSpPr>
+        <p:spPr>
+          <a:xfrm>
+            <a:off x="8915400" y="4983480"/>
+            <a:ext cx="2560320" cy="548640"/>
           </a:xfrm>
           <a:prstGeom prst="rect">
             <a:avLst/>
@@ -3074,7 +2970,7 @@
               <a:buNone/>
             </a:pPr>
             <a:r>
-              <a:rPr lang="en-US" sz="3800" b="1" dirty="0">
+              <a:rPr lang="en-US" sz="3100" b="1" dirty="0">
                 <a:solidFill>
                   <a:srgbClr val="B0842F"/>
                 </a:solidFill>
@@ -3082,22 +2978,22 @@
                 <a:ea typeface="Cambria" pitchFamily="34" charset="-122"/>
                 <a:cs typeface="Cambria" pitchFamily="34" charset="-120"/>
               </a:rPr>
-              <a:t>≈12×</a:t>
-            </a:r>
-            <a:endParaRPr lang="en-US" sz="3800" dirty="0"/>
-          </a:p>
-        </p:txBody>
-      </p:sp>
-      <p:sp>
-        <p:nvSpPr>
-          <p:cNvPr id="29" name="Text 27"/>
-          <p:cNvSpPr/>
-          <p:nvPr/>
-        </p:nvSpPr>
-        <p:spPr>
-          <a:xfrm>
-            <a:off x="8686800" y="5504688"/>
-            <a:ext cx="2971800" cy="365760"/>
+              <a:t>~$130M</a:t>
+            </a:r>
+            <a:endParaRPr lang="en-US" sz="3100" dirty="0"/>
+          </a:p>
+        </p:txBody>
+      </p:sp>
+      <p:sp>
+        <p:nvSpPr>
+          <p:cNvPr id="27" name="Text 25"/>
+          <p:cNvSpPr/>
+          <p:nvPr/>
+        </p:nvSpPr>
+        <p:spPr>
+          <a:xfrm>
+            <a:off x="8778240" y="5522976"/>
+            <a:ext cx="2743200" cy="365760"/>
           </a:xfrm>
           <a:prstGeom prst="rect">
             <a:avLst/>
@@ -3116,7 +3012,7 @@
               <a:buNone/>
             </a:pPr>
             <a:r>
-              <a:rPr lang="en-US" sz="950" dirty="0">
+              <a:rPr lang="en-US" sz="900" dirty="0">
                 <a:solidFill>
                   <a:srgbClr val="9A9482"/>
                 </a:solidFill>
@@ -3124,15 +3020,15 @@
                 <a:ea typeface="Calibri" pitchFamily="34" charset="-122"/>
                 <a:cs typeface="Calibri" pitchFamily="34" charset="-120"/>
               </a:rPr>
-              <a:t>cushion vs. the 29.8 listings the plan targets</a:t>
-            </a:r>
-            <a:endParaRPr lang="en-US" sz="950" dirty="0"/>
-          </a:p>
-        </p:txBody>
-      </p:sp>
-      <p:sp>
-        <p:nvSpPr>
-          <p:cNvPr id="30" name="Text 28"/>
+              <a:t>in homes trading hands each year</a:t>
+            </a:r>
+            <a:endParaRPr lang="en-US" sz="900" dirty="0"/>
+          </a:p>
+        </p:txBody>
+      </p:sp>
+      <p:sp>
+        <p:nvSpPr>
+          <p:cNvPr id="28" name="Text 26"/>
           <p:cNvSpPr/>
           <p:nvPr/>
         </p:nvSpPr>
@@ -3185,7 +3081,7 @@
       </p:sp>
       <p:sp>
         <p:nvSpPr>
-          <p:cNvPr id="31" name="Text 29"/>
+          <p:cNvPr id="29" name="Text 27"/>
           <p:cNvSpPr/>
           <p:nvPr/>
         </p:nvSpPr>

</xml_diff>